<commit_message>
testing ability to update ppt
</commit_message>
<xml_diff>
--- a/565Presentation.pptx
+++ b/565Presentation.pptx
@@ -4605,25 +4605,2347 @@
           </a:p>
         </p:txBody>
       </p:sp>
-      <p:sp>
-        <p:nvSpPr>
-          <p:cNvPr id="3" name="Content Placeholder 2"/>
-          <p:cNvSpPr>
-            <a:spLocks noGrp="1"/>
-          </p:cNvSpPr>
-          <p:nvPr>
-            <p:ph idx="1"/>
-          </p:nvPr>
-        </p:nvSpPr>
-        <p:spPr/>
-        <p:txBody>
-          <a:bodyPr/>
-          <a:lstStyle/>
-          <a:p>
-            <a:endParaRPr lang="en-US"/>
-          </a:p>
-        </p:txBody>
-      </p:sp>
+      <p:grpSp>
+        <p:nvGrpSpPr>
+          <p:cNvPr id="4" name="Group 3"/>
+          <p:cNvGrpSpPr/>
+          <p:nvPr/>
+        </p:nvGrpSpPr>
+        <p:grpSpPr>
+          <a:xfrm>
+            <a:off x="181424" y="1444532"/>
+            <a:ext cx="8603309" cy="4933671"/>
+            <a:chOff x="844637" y="787226"/>
+            <a:chExt cx="10427267" cy="5671191"/>
+          </a:xfrm>
+        </p:grpSpPr>
+        <p:sp>
+          <p:nvSpPr>
+            <p:cNvPr id="5" name="Rectangle 4"/>
+            <p:cNvSpPr/>
+            <p:nvPr/>
+          </p:nvSpPr>
+          <p:spPr>
+            <a:xfrm>
+              <a:off x="844637" y="3677162"/>
+              <a:ext cx="1551398" cy="688369"/>
+            </a:xfrm>
+            <a:prstGeom prst="rect">
+              <a:avLst/>
+            </a:prstGeom>
+            <a:ln>
+              <a:solidFill>
+                <a:schemeClr val="tx1"/>
+              </a:solidFill>
+            </a:ln>
+          </p:spPr>
+          <p:style>
+            <a:lnRef idx="2">
+              <a:schemeClr val="accent6"/>
+            </a:lnRef>
+            <a:fillRef idx="1">
+              <a:schemeClr val="lt1"/>
+            </a:fillRef>
+            <a:effectRef idx="0">
+              <a:schemeClr val="accent6"/>
+            </a:effectRef>
+            <a:fontRef idx="minor">
+              <a:schemeClr val="dk1"/>
+            </a:fontRef>
+          </p:style>
+          <p:txBody>
+            <a:bodyPr rtlCol="0" anchor="ctr"/>
+            <a:lstStyle/>
+            <a:p>
+              <a:pPr algn="ctr"/>
+              <a:r>
+                <a:rPr lang="en-US" sz="1100" dirty="0" smtClean="0"/>
+                <a:t>DTDCPB</a:t>
+              </a:r>
+            </a:p>
+            <a:p>
+              <a:pPr algn="ctr"/>
+              <a:r>
+                <a:rPr lang="en-US" sz="1100" dirty="0" err="1" smtClean="0"/>
+                <a:t>opt+freq</a:t>
+              </a:r>
+              <a:endParaRPr lang="en-US" sz="1100" dirty="0"/>
+            </a:p>
+          </p:txBody>
+        </p:sp>
+        <p:sp>
+          <p:nvSpPr>
+            <p:cNvPr id="6" name="Rectangle 5"/>
+            <p:cNvSpPr/>
+            <p:nvPr/>
+          </p:nvSpPr>
+          <p:spPr>
+            <a:xfrm>
+              <a:off x="3012485" y="3677160"/>
+              <a:ext cx="1571946" cy="688369"/>
+            </a:xfrm>
+            <a:prstGeom prst="rect">
+              <a:avLst/>
+            </a:prstGeom>
+            <a:ln>
+              <a:solidFill>
+                <a:schemeClr val="tx1"/>
+              </a:solidFill>
+            </a:ln>
+          </p:spPr>
+          <p:style>
+            <a:lnRef idx="2">
+              <a:schemeClr val="accent6"/>
+            </a:lnRef>
+            <a:fillRef idx="1">
+              <a:schemeClr val="lt1"/>
+            </a:fillRef>
+            <a:effectRef idx="0">
+              <a:schemeClr val="accent6"/>
+            </a:effectRef>
+            <a:fontRef idx="minor">
+              <a:schemeClr val="dk1"/>
+            </a:fontRef>
+          </p:style>
+          <p:txBody>
+            <a:bodyPr rtlCol="0" anchor="ctr"/>
+            <a:lstStyle/>
+            <a:p>
+              <a:pPr algn="ctr"/>
+              <a:r>
+                <a:rPr lang="en-US" sz="1100" dirty="0" smtClean="0"/>
+                <a:t>DTDCPB + E</a:t>
+              </a:r>
+              <a:r>
+                <a:rPr lang="en-US" sz="1100" baseline="-25000" dirty="0"/>
+                <a:t>2</a:t>
+              </a:r>
+              <a:r>
+                <a:rPr lang="en-US" sz="1100" baseline="30000" dirty="0" smtClean="0"/>
+                <a:t>field </a:t>
+              </a:r>
+              <a:r>
+                <a:rPr lang="en-US" sz="1100" dirty="0" smtClean="0"/>
+                <a:t> </a:t>
+              </a:r>
+              <a:r>
+                <a:rPr lang="en-US" sz="1100" dirty="0" err="1" smtClean="0"/>
+                <a:t>opt+freq</a:t>
+              </a:r>
+              <a:endParaRPr lang="en-US" sz="1100" dirty="0"/>
+            </a:p>
+          </p:txBody>
+        </p:sp>
+        <p:sp>
+          <p:nvSpPr>
+            <p:cNvPr id="7" name="Rectangle 6"/>
+            <p:cNvSpPr/>
+            <p:nvPr/>
+          </p:nvSpPr>
+          <p:spPr>
+            <a:xfrm>
+              <a:off x="3012485" y="2829492"/>
+              <a:ext cx="1571946" cy="688369"/>
+            </a:xfrm>
+            <a:prstGeom prst="rect">
+              <a:avLst/>
+            </a:prstGeom>
+            <a:ln>
+              <a:solidFill>
+                <a:schemeClr val="tx1"/>
+              </a:solidFill>
+            </a:ln>
+          </p:spPr>
+          <p:style>
+            <a:lnRef idx="2">
+              <a:schemeClr val="accent6"/>
+            </a:lnRef>
+            <a:fillRef idx="1">
+              <a:schemeClr val="lt1"/>
+            </a:fillRef>
+            <a:effectRef idx="0">
+              <a:schemeClr val="accent6"/>
+            </a:effectRef>
+            <a:fontRef idx="minor">
+              <a:schemeClr val="dk1"/>
+            </a:fontRef>
+          </p:style>
+          <p:txBody>
+            <a:bodyPr rtlCol="0" anchor="ctr"/>
+            <a:lstStyle/>
+            <a:p>
+              <a:pPr algn="ctr"/>
+              <a:r>
+                <a:rPr lang="en-US" sz="1100" dirty="0" smtClean="0"/>
+                <a:t>DTDCPB + E</a:t>
+              </a:r>
+              <a:r>
+                <a:rPr lang="en-US" sz="1100" baseline="-25000" dirty="0" smtClean="0"/>
+                <a:t>1</a:t>
+              </a:r>
+              <a:r>
+                <a:rPr lang="en-US" sz="1100" baseline="30000" dirty="0" smtClean="0"/>
+                <a:t>field </a:t>
+              </a:r>
+              <a:r>
+                <a:rPr lang="en-US" sz="1100" dirty="0" smtClean="0"/>
+                <a:t> </a:t>
+              </a:r>
+              <a:r>
+                <a:rPr lang="en-US" sz="1100" dirty="0" err="1" smtClean="0"/>
+                <a:t>opt+freq</a:t>
+              </a:r>
+              <a:endParaRPr lang="en-US" sz="1100" dirty="0"/>
+            </a:p>
+          </p:txBody>
+        </p:sp>
+        <p:sp>
+          <p:nvSpPr>
+            <p:cNvPr id="8" name="Rectangle 7"/>
+            <p:cNvSpPr/>
+            <p:nvPr/>
+          </p:nvSpPr>
+          <p:spPr>
+            <a:xfrm>
+              <a:off x="3012485" y="4524828"/>
+              <a:ext cx="1571946" cy="688369"/>
+            </a:xfrm>
+            <a:prstGeom prst="rect">
+              <a:avLst/>
+            </a:prstGeom>
+            <a:ln>
+              <a:solidFill>
+                <a:schemeClr val="tx1"/>
+              </a:solidFill>
+            </a:ln>
+          </p:spPr>
+          <p:style>
+            <a:lnRef idx="2">
+              <a:schemeClr val="accent6"/>
+            </a:lnRef>
+            <a:fillRef idx="1">
+              <a:schemeClr val="lt1"/>
+            </a:fillRef>
+            <a:effectRef idx="0">
+              <a:schemeClr val="accent6"/>
+            </a:effectRef>
+            <a:fontRef idx="minor">
+              <a:schemeClr val="dk1"/>
+            </a:fontRef>
+          </p:style>
+          <p:txBody>
+            <a:bodyPr rtlCol="0" anchor="ctr"/>
+            <a:lstStyle/>
+            <a:p>
+              <a:pPr algn="ctr"/>
+              <a:r>
+                <a:rPr lang="en-US" sz="1100" dirty="0" smtClean="0"/>
+                <a:t>DTDCPB + E</a:t>
+              </a:r>
+              <a:r>
+                <a:rPr lang="en-US" sz="1100" baseline="-25000" dirty="0"/>
+                <a:t>3</a:t>
+              </a:r>
+              <a:r>
+                <a:rPr lang="en-US" sz="1100" baseline="30000" dirty="0" smtClean="0"/>
+                <a:t>field </a:t>
+              </a:r>
+              <a:r>
+                <a:rPr lang="en-US" sz="1100" dirty="0" smtClean="0"/>
+                <a:t> </a:t>
+              </a:r>
+              <a:r>
+                <a:rPr lang="en-US" sz="1100" dirty="0" err="1" smtClean="0"/>
+                <a:t>opt+freq</a:t>
+              </a:r>
+              <a:endParaRPr lang="en-US" sz="1100" dirty="0"/>
+            </a:p>
+          </p:txBody>
+        </p:sp>
+        <p:sp>
+          <p:nvSpPr>
+            <p:cNvPr id="9" name="Rectangle 8"/>
+            <p:cNvSpPr/>
+            <p:nvPr/>
+          </p:nvSpPr>
+          <p:spPr>
+            <a:xfrm>
+              <a:off x="5241979" y="2829492"/>
+              <a:ext cx="1571946" cy="688369"/>
+            </a:xfrm>
+            <a:prstGeom prst="rect">
+              <a:avLst/>
+            </a:prstGeom>
+            <a:ln>
+              <a:solidFill>
+                <a:schemeClr val="tx1"/>
+              </a:solidFill>
+            </a:ln>
+          </p:spPr>
+          <p:style>
+            <a:lnRef idx="2">
+              <a:schemeClr val="accent6"/>
+            </a:lnRef>
+            <a:fillRef idx="1">
+              <a:schemeClr val="lt1"/>
+            </a:fillRef>
+            <a:effectRef idx="0">
+              <a:schemeClr val="accent6"/>
+            </a:effectRef>
+            <a:fontRef idx="minor">
+              <a:schemeClr val="dk1"/>
+            </a:fontRef>
+          </p:style>
+          <p:txBody>
+            <a:bodyPr rtlCol="0" anchor="ctr"/>
+            <a:lstStyle/>
+            <a:p>
+              <a:pPr algn="ctr"/>
+              <a:r>
+                <a:rPr lang="en-US" sz="1100" dirty="0" smtClean="0"/>
+                <a:t>DTDCPB + E</a:t>
+              </a:r>
+              <a:r>
+                <a:rPr lang="en-US" sz="1100" baseline="-25000" dirty="0" smtClean="0"/>
+                <a:t>1</a:t>
+              </a:r>
+              <a:r>
+                <a:rPr lang="en-US" sz="1100" baseline="30000" dirty="0" smtClean="0"/>
+                <a:t>field </a:t>
+              </a:r>
+              <a:r>
+                <a:rPr lang="en-US" sz="1100" dirty="0" smtClean="0"/>
+                <a:t> Thermal Sampling</a:t>
+              </a:r>
+              <a:endParaRPr lang="en-US" sz="1100" dirty="0"/>
+            </a:p>
+          </p:txBody>
+        </p:sp>
+        <p:sp>
+          <p:nvSpPr>
+            <p:cNvPr id="10" name="Rectangle 9"/>
+            <p:cNvSpPr/>
+            <p:nvPr/>
+          </p:nvSpPr>
+          <p:spPr>
+            <a:xfrm>
+              <a:off x="5241979" y="3677160"/>
+              <a:ext cx="1571946" cy="688369"/>
+            </a:xfrm>
+            <a:prstGeom prst="rect">
+              <a:avLst/>
+            </a:prstGeom>
+            <a:ln>
+              <a:solidFill>
+                <a:schemeClr val="tx1"/>
+              </a:solidFill>
+            </a:ln>
+          </p:spPr>
+          <p:style>
+            <a:lnRef idx="2">
+              <a:schemeClr val="accent6"/>
+            </a:lnRef>
+            <a:fillRef idx="1">
+              <a:schemeClr val="lt1"/>
+            </a:fillRef>
+            <a:effectRef idx="0">
+              <a:schemeClr val="accent6"/>
+            </a:effectRef>
+            <a:fontRef idx="minor">
+              <a:schemeClr val="dk1"/>
+            </a:fontRef>
+          </p:style>
+          <p:txBody>
+            <a:bodyPr rtlCol="0" anchor="ctr"/>
+            <a:lstStyle/>
+            <a:p>
+              <a:pPr algn="ctr"/>
+              <a:r>
+                <a:rPr lang="en-US" sz="1100" dirty="0" smtClean="0"/>
+                <a:t>DTDCPB + E</a:t>
+              </a:r>
+              <a:r>
+                <a:rPr lang="en-US" sz="1100" baseline="-25000" dirty="0"/>
+                <a:t>2</a:t>
+              </a:r>
+              <a:r>
+                <a:rPr lang="en-US" sz="1100" baseline="30000" dirty="0" smtClean="0"/>
+                <a:t>field </a:t>
+              </a:r>
+              <a:r>
+                <a:rPr lang="en-US" sz="1100" dirty="0" smtClean="0"/>
+                <a:t> Thermal Sampling</a:t>
+              </a:r>
+              <a:endParaRPr lang="en-US" sz="1100" dirty="0"/>
+            </a:p>
+          </p:txBody>
+        </p:sp>
+        <p:sp>
+          <p:nvSpPr>
+            <p:cNvPr id="11" name="Rectangle 10"/>
+            <p:cNvSpPr/>
+            <p:nvPr/>
+          </p:nvSpPr>
+          <p:spPr>
+            <a:xfrm>
+              <a:off x="5241979" y="4524827"/>
+              <a:ext cx="1571946" cy="688369"/>
+            </a:xfrm>
+            <a:prstGeom prst="rect">
+              <a:avLst/>
+            </a:prstGeom>
+            <a:ln>
+              <a:solidFill>
+                <a:schemeClr val="tx1"/>
+              </a:solidFill>
+            </a:ln>
+          </p:spPr>
+          <p:style>
+            <a:lnRef idx="2">
+              <a:schemeClr val="accent6"/>
+            </a:lnRef>
+            <a:fillRef idx="1">
+              <a:schemeClr val="lt1"/>
+            </a:fillRef>
+            <a:effectRef idx="0">
+              <a:schemeClr val="accent6"/>
+            </a:effectRef>
+            <a:fontRef idx="minor">
+              <a:schemeClr val="dk1"/>
+            </a:fontRef>
+          </p:style>
+          <p:txBody>
+            <a:bodyPr rtlCol="0" anchor="ctr"/>
+            <a:lstStyle/>
+            <a:p>
+              <a:pPr algn="ctr"/>
+              <a:r>
+                <a:rPr lang="en-US" sz="1100" dirty="0" smtClean="0"/>
+                <a:t>DTDCPB + E</a:t>
+              </a:r>
+              <a:r>
+                <a:rPr lang="en-US" sz="1100" baseline="-25000" dirty="0"/>
+                <a:t>3</a:t>
+              </a:r>
+              <a:r>
+                <a:rPr lang="en-US" sz="1100" baseline="30000" dirty="0" smtClean="0"/>
+                <a:t>field </a:t>
+              </a:r>
+              <a:r>
+                <a:rPr lang="en-US" sz="1100" dirty="0" smtClean="0"/>
+                <a:t> Thermal Sampling</a:t>
+              </a:r>
+              <a:endParaRPr lang="en-US" sz="1100" dirty="0"/>
+            </a:p>
+          </p:txBody>
+        </p:sp>
+        <p:cxnSp>
+          <p:nvCxnSpPr>
+            <p:cNvPr id="12" name="Elbow Connector 11"/>
+            <p:cNvCxnSpPr>
+              <a:stCxn id="5" idx="3"/>
+              <a:endCxn id="7" idx="1"/>
+            </p:cNvCxnSpPr>
+            <p:nvPr/>
+          </p:nvCxnSpPr>
+          <p:spPr>
+            <a:xfrm flipV="1">
+              <a:off x="2396035" y="3173677"/>
+              <a:ext cx="616450" cy="847670"/>
+            </a:xfrm>
+            <a:prstGeom prst="bentConnector3">
+              <a:avLst/>
+            </a:prstGeom>
+            <a:ln>
+              <a:solidFill>
+                <a:schemeClr val="tx1">
+                  <a:lumMod val="50000"/>
+                  <a:lumOff val="50000"/>
+                </a:schemeClr>
+              </a:solidFill>
+              <a:tailEnd type="triangle"/>
+            </a:ln>
+          </p:spPr>
+          <p:style>
+            <a:lnRef idx="1">
+              <a:schemeClr val="accent1"/>
+            </a:lnRef>
+            <a:fillRef idx="0">
+              <a:schemeClr val="accent1"/>
+            </a:fillRef>
+            <a:effectRef idx="0">
+              <a:schemeClr val="accent1"/>
+            </a:effectRef>
+            <a:fontRef idx="minor">
+              <a:schemeClr val="tx1"/>
+            </a:fontRef>
+          </p:style>
+        </p:cxnSp>
+        <p:cxnSp>
+          <p:nvCxnSpPr>
+            <p:cNvPr id="13" name="Straight Connector 12"/>
+            <p:cNvCxnSpPr>
+              <a:stCxn id="5" idx="3"/>
+              <a:endCxn id="6" idx="1"/>
+            </p:cNvCxnSpPr>
+            <p:nvPr/>
+          </p:nvCxnSpPr>
+          <p:spPr>
+            <a:xfrm flipV="1">
+              <a:off x="2396035" y="4021345"/>
+              <a:ext cx="616450" cy="2"/>
+            </a:xfrm>
+            <a:prstGeom prst="line">
+              <a:avLst/>
+            </a:prstGeom>
+            <a:ln>
+              <a:solidFill>
+                <a:schemeClr val="tx1">
+                  <a:lumMod val="50000"/>
+                  <a:lumOff val="50000"/>
+                </a:schemeClr>
+              </a:solidFill>
+            </a:ln>
+          </p:spPr>
+          <p:style>
+            <a:lnRef idx="1">
+              <a:schemeClr val="accent1"/>
+            </a:lnRef>
+            <a:fillRef idx="0">
+              <a:schemeClr val="accent1"/>
+            </a:fillRef>
+            <a:effectRef idx="0">
+              <a:schemeClr val="accent1"/>
+            </a:effectRef>
+            <a:fontRef idx="minor">
+              <a:schemeClr val="tx1"/>
+            </a:fontRef>
+          </p:style>
+        </p:cxnSp>
+        <p:cxnSp>
+          <p:nvCxnSpPr>
+            <p:cNvPr id="14" name="Elbow Connector 13"/>
+            <p:cNvCxnSpPr>
+              <a:stCxn id="5" idx="3"/>
+              <a:endCxn id="8" idx="1"/>
+            </p:cNvCxnSpPr>
+            <p:nvPr/>
+          </p:nvCxnSpPr>
+          <p:spPr>
+            <a:xfrm>
+              <a:off x="2396035" y="4021347"/>
+              <a:ext cx="616450" cy="847666"/>
+            </a:xfrm>
+            <a:prstGeom prst="bentConnector3">
+              <a:avLst/>
+            </a:prstGeom>
+            <a:ln>
+              <a:solidFill>
+                <a:schemeClr val="tx1">
+                  <a:lumMod val="50000"/>
+                  <a:lumOff val="50000"/>
+                </a:schemeClr>
+              </a:solidFill>
+              <a:tailEnd type="triangle"/>
+            </a:ln>
+          </p:spPr>
+          <p:style>
+            <a:lnRef idx="1">
+              <a:schemeClr val="accent1"/>
+            </a:lnRef>
+            <a:fillRef idx="0">
+              <a:schemeClr val="accent1"/>
+            </a:fillRef>
+            <a:effectRef idx="0">
+              <a:schemeClr val="accent1"/>
+            </a:effectRef>
+            <a:fontRef idx="minor">
+              <a:schemeClr val="tx1"/>
+            </a:fontRef>
+          </p:style>
+        </p:cxnSp>
+        <p:cxnSp>
+          <p:nvCxnSpPr>
+            <p:cNvPr id="15" name="Straight Arrow Connector 14"/>
+            <p:cNvCxnSpPr>
+              <a:stCxn id="7" idx="3"/>
+              <a:endCxn id="9" idx="1"/>
+            </p:cNvCxnSpPr>
+            <p:nvPr/>
+          </p:nvCxnSpPr>
+          <p:spPr>
+            <a:xfrm>
+              <a:off x="4584431" y="3173677"/>
+              <a:ext cx="657548" cy="0"/>
+            </a:xfrm>
+            <a:prstGeom prst="straightConnector1">
+              <a:avLst/>
+            </a:prstGeom>
+            <a:ln>
+              <a:solidFill>
+                <a:schemeClr val="tx1">
+                  <a:lumMod val="50000"/>
+                  <a:lumOff val="50000"/>
+                </a:schemeClr>
+              </a:solidFill>
+              <a:tailEnd type="triangle"/>
+            </a:ln>
+          </p:spPr>
+          <p:style>
+            <a:lnRef idx="1">
+              <a:schemeClr val="accent1"/>
+            </a:lnRef>
+            <a:fillRef idx="0">
+              <a:schemeClr val="accent1"/>
+            </a:fillRef>
+            <a:effectRef idx="0">
+              <a:schemeClr val="accent1"/>
+            </a:effectRef>
+            <a:fontRef idx="minor">
+              <a:schemeClr val="tx1"/>
+            </a:fontRef>
+          </p:style>
+        </p:cxnSp>
+        <p:cxnSp>
+          <p:nvCxnSpPr>
+            <p:cNvPr id="16" name="Straight Arrow Connector 15"/>
+            <p:cNvCxnSpPr>
+              <a:stCxn id="6" idx="3"/>
+              <a:endCxn id="10" idx="1"/>
+            </p:cNvCxnSpPr>
+            <p:nvPr/>
+          </p:nvCxnSpPr>
+          <p:spPr>
+            <a:xfrm>
+              <a:off x="4584431" y="4021345"/>
+              <a:ext cx="657548" cy="0"/>
+            </a:xfrm>
+            <a:prstGeom prst="straightConnector1">
+              <a:avLst/>
+            </a:prstGeom>
+            <a:ln>
+              <a:solidFill>
+                <a:schemeClr val="tx1">
+                  <a:lumMod val="50000"/>
+                  <a:lumOff val="50000"/>
+                </a:schemeClr>
+              </a:solidFill>
+              <a:tailEnd type="triangle"/>
+            </a:ln>
+          </p:spPr>
+          <p:style>
+            <a:lnRef idx="1">
+              <a:schemeClr val="accent1"/>
+            </a:lnRef>
+            <a:fillRef idx="0">
+              <a:schemeClr val="accent1"/>
+            </a:fillRef>
+            <a:effectRef idx="0">
+              <a:schemeClr val="accent1"/>
+            </a:effectRef>
+            <a:fontRef idx="minor">
+              <a:schemeClr val="tx1"/>
+            </a:fontRef>
+          </p:style>
+        </p:cxnSp>
+        <p:cxnSp>
+          <p:nvCxnSpPr>
+            <p:cNvPr id="17" name="Straight Arrow Connector 16"/>
+            <p:cNvCxnSpPr>
+              <a:stCxn id="8" idx="3"/>
+              <a:endCxn id="11" idx="1"/>
+            </p:cNvCxnSpPr>
+            <p:nvPr/>
+          </p:nvCxnSpPr>
+          <p:spPr>
+            <a:xfrm flipV="1">
+              <a:off x="4584431" y="4869012"/>
+              <a:ext cx="657548" cy="1"/>
+            </a:xfrm>
+            <a:prstGeom prst="straightConnector1">
+              <a:avLst/>
+            </a:prstGeom>
+            <a:ln>
+              <a:solidFill>
+                <a:schemeClr val="tx1">
+                  <a:lumMod val="50000"/>
+                  <a:lumOff val="50000"/>
+                </a:schemeClr>
+              </a:solidFill>
+              <a:tailEnd type="triangle"/>
+            </a:ln>
+          </p:spPr>
+          <p:style>
+            <a:lnRef idx="1">
+              <a:schemeClr val="accent1"/>
+            </a:lnRef>
+            <a:fillRef idx="0">
+              <a:schemeClr val="accent1"/>
+            </a:fillRef>
+            <a:effectRef idx="0">
+              <a:schemeClr val="accent1"/>
+            </a:effectRef>
+            <a:fontRef idx="minor">
+              <a:schemeClr val="tx1"/>
+            </a:fontRef>
+          </p:style>
+        </p:cxnSp>
+        <p:sp>
+          <p:nvSpPr>
+            <p:cNvPr id="18" name="Rectangle 17"/>
+            <p:cNvSpPr/>
+            <p:nvPr/>
+          </p:nvSpPr>
+          <p:spPr>
+            <a:xfrm>
+              <a:off x="7471473" y="1585043"/>
+              <a:ext cx="1571946" cy="390634"/>
+            </a:xfrm>
+            <a:prstGeom prst="rect">
+              <a:avLst/>
+            </a:prstGeom>
+            <a:ln>
+              <a:solidFill>
+                <a:schemeClr val="tx1"/>
+              </a:solidFill>
+            </a:ln>
+          </p:spPr>
+          <p:style>
+            <a:lnRef idx="2">
+              <a:schemeClr val="accent6"/>
+            </a:lnRef>
+            <a:fillRef idx="1">
+              <a:schemeClr val="lt1"/>
+            </a:fillRef>
+            <a:effectRef idx="0">
+              <a:schemeClr val="accent6"/>
+            </a:effectRef>
+            <a:fontRef idx="minor">
+              <a:schemeClr val="dk1"/>
+            </a:fontRef>
+          </p:style>
+          <p:txBody>
+            <a:bodyPr rtlCol="0" anchor="ctr"/>
+            <a:lstStyle/>
+            <a:p>
+              <a:pPr algn="ctr"/>
+              <a:r>
+                <a:rPr lang="en-US" sz="1100" dirty="0" smtClean="0"/>
+                <a:t>E</a:t>
+              </a:r>
+              <a:r>
+                <a:rPr lang="en-US" sz="1100" baseline="-25000" dirty="0"/>
+                <a:t>1</a:t>
+              </a:r>
+              <a:r>
+                <a:rPr lang="en-US" sz="1100" baseline="30000" dirty="0" smtClean="0"/>
+                <a:t>field </a:t>
+              </a:r>
+              <a:r>
+                <a:rPr lang="en-US" sz="1100" dirty="0" smtClean="0"/>
+                <a:t> BOMD Trajectory 1</a:t>
+              </a:r>
+              <a:endParaRPr lang="en-US" sz="1100" dirty="0"/>
+            </a:p>
+          </p:txBody>
+        </p:sp>
+        <p:sp>
+          <p:nvSpPr>
+            <p:cNvPr id="19" name="Rectangle 18"/>
+            <p:cNvSpPr/>
+            <p:nvPr/>
+          </p:nvSpPr>
+          <p:spPr>
+            <a:xfrm>
+              <a:off x="7471473" y="2145482"/>
+              <a:ext cx="1571946" cy="390634"/>
+            </a:xfrm>
+            <a:prstGeom prst="rect">
+              <a:avLst/>
+            </a:prstGeom>
+            <a:ln>
+              <a:solidFill>
+                <a:schemeClr val="tx1"/>
+              </a:solidFill>
+            </a:ln>
+          </p:spPr>
+          <p:style>
+            <a:lnRef idx="2">
+              <a:schemeClr val="accent6"/>
+            </a:lnRef>
+            <a:fillRef idx="1">
+              <a:schemeClr val="lt1"/>
+            </a:fillRef>
+            <a:effectRef idx="0">
+              <a:schemeClr val="accent6"/>
+            </a:effectRef>
+            <a:fontRef idx="minor">
+              <a:schemeClr val="dk1"/>
+            </a:fontRef>
+          </p:style>
+          <p:txBody>
+            <a:bodyPr rtlCol="0" anchor="ctr"/>
+            <a:lstStyle/>
+            <a:p>
+              <a:pPr algn="ctr"/>
+              <a:r>
+                <a:rPr lang="en-US" sz="1100" dirty="0" smtClean="0"/>
+                <a:t>E</a:t>
+              </a:r>
+              <a:r>
+                <a:rPr lang="en-US" sz="1100" baseline="-25000" dirty="0" smtClean="0"/>
+                <a:t>1</a:t>
+              </a:r>
+              <a:r>
+                <a:rPr lang="en-US" sz="1100" baseline="30000" dirty="0" smtClean="0"/>
+                <a:t>field </a:t>
+              </a:r>
+              <a:r>
+                <a:rPr lang="en-US" sz="1100" dirty="0" smtClean="0"/>
+                <a:t> BOMD Trajectory 2</a:t>
+              </a:r>
+              <a:endParaRPr lang="en-US" sz="1100" dirty="0"/>
+            </a:p>
+          </p:txBody>
+        </p:sp>
+        <p:sp>
+          <p:nvSpPr>
+            <p:cNvPr id="20" name="Rectangle 19"/>
+            <p:cNvSpPr/>
+            <p:nvPr/>
+          </p:nvSpPr>
+          <p:spPr>
+            <a:xfrm>
+              <a:off x="7471473" y="2705921"/>
+              <a:ext cx="1571946" cy="390634"/>
+            </a:xfrm>
+            <a:prstGeom prst="rect">
+              <a:avLst/>
+            </a:prstGeom>
+            <a:ln>
+              <a:solidFill>
+                <a:schemeClr val="tx1"/>
+              </a:solidFill>
+            </a:ln>
+          </p:spPr>
+          <p:style>
+            <a:lnRef idx="2">
+              <a:schemeClr val="accent6"/>
+            </a:lnRef>
+            <a:fillRef idx="1">
+              <a:schemeClr val="lt1"/>
+            </a:fillRef>
+            <a:effectRef idx="0">
+              <a:schemeClr val="accent6"/>
+            </a:effectRef>
+            <a:fontRef idx="minor">
+              <a:schemeClr val="dk1"/>
+            </a:fontRef>
+          </p:style>
+          <p:txBody>
+            <a:bodyPr rtlCol="0" anchor="ctr"/>
+            <a:lstStyle/>
+            <a:p>
+              <a:pPr algn="ctr"/>
+              <a:r>
+                <a:rPr lang="en-US" sz="1100" dirty="0" smtClean="0"/>
+                <a:t>E</a:t>
+              </a:r>
+              <a:r>
+                <a:rPr lang="en-US" sz="1100" baseline="-25000" dirty="0" smtClean="0"/>
+                <a:t>1</a:t>
+              </a:r>
+              <a:r>
+                <a:rPr lang="en-US" sz="1100" baseline="30000" dirty="0" smtClean="0"/>
+                <a:t>field </a:t>
+              </a:r>
+              <a:r>
+                <a:rPr lang="en-US" sz="1100" dirty="0" smtClean="0"/>
+                <a:t> BOMD Trajectory 3</a:t>
+              </a:r>
+              <a:endParaRPr lang="en-US" sz="1100" dirty="0"/>
+            </a:p>
+          </p:txBody>
+        </p:sp>
+        <p:sp>
+          <p:nvSpPr>
+            <p:cNvPr id="21" name="Rectangle 20"/>
+            <p:cNvSpPr/>
+            <p:nvPr/>
+          </p:nvSpPr>
+          <p:spPr>
+            <a:xfrm>
+              <a:off x="7471473" y="3265974"/>
+              <a:ext cx="1571946" cy="390634"/>
+            </a:xfrm>
+            <a:prstGeom prst="rect">
+              <a:avLst/>
+            </a:prstGeom>
+            <a:ln>
+              <a:solidFill>
+                <a:schemeClr val="tx1"/>
+              </a:solidFill>
+            </a:ln>
+          </p:spPr>
+          <p:style>
+            <a:lnRef idx="2">
+              <a:schemeClr val="accent6"/>
+            </a:lnRef>
+            <a:fillRef idx="1">
+              <a:schemeClr val="lt1"/>
+            </a:fillRef>
+            <a:effectRef idx="0">
+              <a:schemeClr val="accent6"/>
+            </a:effectRef>
+            <a:fontRef idx="minor">
+              <a:schemeClr val="dk1"/>
+            </a:fontRef>
+          </p:style>
+          <p:txBody>
+            <a:bodyPr rtlCol="0" anchor="ctr"/>
+            <a:lstStyle/>
+            <a:p>
+              <a:pPr algn="ctr"/>
+              <a:r>
+                <a:rPr lang="en-US" sz="1100" dirty="0" smtClean="0"/>
+                <a:t>E</a:t>
+              </a:r>
+              <a:r>
+                <a:rPr lang="en-US" sz="1100" baseline="-25000" dirty="0"/>
+                <a:t>2</a:t>
+              </a:r>
+              <a:r>
+                <a:rPr lang="en-US" sz="1100" baseline="30000" dirty="0" smtClean="0"/>
+                <a:t>field </a:t>
+              </a:r>
+              <a:r>
+                <a:rPr lang="en-US" sz="1100" dirty="0" smtClean="0"/>
+                <a:t> BOMD Trajectory 1</a:t>
+              </a:r>
+              <a:endParaRPr lang="en-US" sz="1100" dirty="0"/>
+            </a:p>
+          </p:txBody>
+        </p:sp>
+        <p:sp>
+          <p:nvSpPr>
+            <p:cNvPr id="22" name="Rectangle 21"/>
+            <p:cNvSpPr/>
+            <p:nvPr/>
+          </p:nvSpPr>
+          <p:spPr>
+            <a:xfrm>
+              <a:off x="7471473" y="3826027"/>
+              <a:ext cx="1571946" cy="390634"/>
+            </a:xfrm>
+            <a:prstGeom prst="rect">
+              <a:avLst/>
+            </a:prstGeom>
+            <a:ln>
+              <a:solidFill>
+                <a:schemeClr val="tx1"/>
+              </a:solidFill>
+            </a:ln>
+          </p:spPr>
+          <p:style>
+            <a:lnRef idx="2">
+              <a:schemeClr val="accent6"/>
+            </a:lnRef>
+            <a:fillRef idx="1">
+              <a:schemeClr val="lt1"/>
+            </a:fillRef>
+            <a:effectRef idx="0">
+              <a:schemeClr val="accent6"/>
+            </a:effectRef>
+            <a:fontRef idx="minor">
+              <a:schemeClr val="dk1"/>
+            </a:fontRef>
+          </p:style>
+          <p:txBody>
+            <a:bodyPr rtlCol="0" anchor="ctr"/>
+            <a:lstStyle/>
+            <a:p>
+              <a:pPr algn="ctr"/>
+              <a:r>
+                <a:rPr lang="en-US" sz="1100" dirty="0" smtClean="0"/>
+                <a:t>E</a:t>
+              </a:r>
+              <a:r>
+                <a:rPr lang="en-US" sz="1100" baseline="-25000" dirty="0"/>
+                <a:t>2</a:t>
+              </a:r>
+              <a:r>
+                <a:rPr lang="en-US" sz="1100" baseline="30000" dirty="0" smtClean="0"/>
+                <a:t>field </a:t>
+              </a:r>
+              <a:r>
+                <a:rPr lang="en-US" sz="1100" dirty="0" smtClean="0"/>
+                <a:t> BOMD Trajectory 2</a:t>
+              </a:r>
+              <a:endParaRPr lang="en-US" sz="1100" dirty="0"/>
+            </a:p>
+          </p:txBody>
+        </p:sp>
+        <p:sp>
+          <p:nvSpPr>
+            <p:cNvPr id="23" name="Rectangle 22"/>
+            <p:cNvSpPr/>
+            <p:nvPr/>
+          </p:nvSpPr>
+          <p:spPr>
+            <a:xfrm>
+              <a:off x="7471473" y="4386466"/>
+              <a:ext cx="1571946" cy="390634"/>
+            </a:xfrm>
+            <a:prstGeom prst="rect">
+              <a:avLst/>
+            </a:prstGeom>
+            <a:ln>
+              <a:solidFill>
+                <a:schemeClr val="tx1"/>
+              </a:solidFill>
+            </a:ln>
+          </p:spPr>
+          <p:style>
+            <a:lnRef idx="2">
+              <a:schemeClr val="accent6"/>
+            </a:lnRef>
+            <a:fillRef idx="1">
+              <a:schemeClr val="lt1"/>
+            </a:fillRef>
+            <a:effectRef idx="0">
+              <a:schemeClr val="accent6"/>
+            </a:effectRef>
+            <a:fontRef idx="minor">
+              <a:schemeClr val="dk1"/>
+            </a:fontRef>
+          </p:style>
+          <p:txBody>
+            <a:bodyPr rtlCol="0" anchor="ctr"/>
+            <a:lstStyle/>
+            <a:p>
+              <a:pPr algn="ctr"/>
+              <a:r>
+                <a:rPr lang="en-US" sz="1100" dirty="0" smtClean="0"/>
+                <a:t>E</a:t>
+              </a:r>
+              <a:r>
+                <a:rPr lang="en-US" sz="1100" baseline="-25000" dirty="0"/>
+                <a:t>2</a:t>
+              </a:r>
+              <a:r>
+                <a:rPr lang="en-US" sz="1100" baseline="30000" dirty="0" smtClean="0"/>
+                <a:t>field </a:t>
+              </a:r>
+              <a:r>
+                <a:rPr lang="en-US" sz="1100" dirty="0" smtClean="0"/>
+                <a:t> BOMD Trajectory 3</a:t>
+              </a:r>
+              <a:endParaRPr lang="en-US" sz="1100" dirty="0"/>
+            </a:p>
+          </p:txBody>
+        </p:sp>
+        <p:sp>
+          <p:nvSpPr>
+            <p:cNvPr id="24" name="Rectangle 23"/>
+            <p:cNvSpPr/>
+            <p:nvPr/>
+          </p:nvSpPr>
+          <p:spPr>
+            <a:xfrm>
+              <a:off x="7471473" y="4946905"/>
+              <a:ext cx="1571946" cy="390634"/>
+            </a:xfrm>
+            <a:prstGeom prst="rect">
+              <a:avLst/>
+            </a:prstGeom>
+            <a:ln>
+              <a:solidFill>
+                <a:schemeClr val="tx1"/>
+              </a:solidFill>
+            </a:ln>
+          </p:spPr>
+          <p:style>
+            <a:lnRef idx="2">
+              <a:schemeClr val="accent6"/>
+            </a:lnRef>
+            <a:fillRef idx="1">
+              <a:schemeClr val="lt1"/>
+            </a:fillRef>
+            <a:effectRef idx="0">
+              <a:schemeClr val="accent6"/>
+            </a:effectRef>
+            <a:fontRef idx="minor">
+              <a:schemeClr val="dk1"/>
+            </a:fontRef>
+          </p:style>
+          <p:txBody>
+            <a:bodyPr rtlCol="0" anchor="ctr"/>
+            <a:lstStyle/>
+            <a:p>
+              <a:pPr algn="ctr"/>
+              <a:r>
+                <a:rPr lang="en-US" sz="1100" dirty="0" smtClean="0"/>
+                <a:t>E</a:t>
+              </a:r>
+              <a:r>
+                <a:rPr lang="en-US" sz="1100" baseline="-25000" dirty="0"/>
+                <a:t>3</a:t>
+              </a:r>
+              <a:r>
+                <a:rPr lang="en-US" sz="1100" baseline="30000" dirty="0" smtClean="0"/>
+                <a:t>field </a:t>
+              </a:r>
+              <a:r>
+                <a:rPr lang="en-US" sz="1100" dirty="0" smtClean="0"/>
+                <a:t> BOMD Trajectory 1</a:t>
+              </a:r>
+              <a:endParaRPr lang="en-US" sz="1100" dirty="0"/>
+            </a:p>
+          </p:txBody>
+        </p:sp>
+        <p:sp>
+          <p:nvSpPr>
+            <p:cNvPr id="25" name="Rectangle 24"/>
+            <p:cNvSpPr/>
+            <p:nvPr/>
+          </p:nvSpPr>
+          <p:spPr>
+            <a:xfrm>
+              <a:off x="7471473" y="5507344"/>
+              <a:ext cx="1571946" cy="390634"/>
+            </a:xfrm>
+            <a:prstGeom prst="rect">
+              <a:avLst/>
+            </a:prstGeom>
+            <a:ln>
+              <a:solidFill>
+                <a:schemeClr val="tx1"/>
+              </a:solidFill>
+            </a:ln>
+          </p:spPr>
+          <p:style>
+            <a:lnRef idx="2">
+              <a:schemeClr val="accent6"/>
+            </a:lnRef>
+            <a:fillRef idx="1">
+              <a:schemeClr val="lt1"/>
+            </a:fillRef>
+            <a:effectRef idx="0">
+              <a:schemeClr val="accent6"/>
+            </a:effectRef>
+            <a:fontRef idx="minor">
+              <a:schemeClr val="dk1"/>
+            </a:fontRef>
+          </p:style>
+          <p:txBody>
+            <a:bodyPr rtlCol="0" anchor="ctr"/>
+            <a:lstStyle/>
+            <a:p>
+              <a:pPr algn="ctr"/>
+              <a:r>
+                <a:rPr lang="en-US" sz="1100" dirty="0" smtClean="0"/>
+                <a:t>E</a:t>
+              </a:r>
+              <a:r>
+                <a:rPr lang="en-US" sz="1100" baseline="-25000" dirty="0"/>
+                <a:t>3</a:t>
+              </a:r>
+              <a:r>
+                <a:rPr lang="en-US" sz="1100" baseline="30000" dirty="0" smtClean="0"/>
+                <a:t>field </a:t>
+              </a:r>
+              <a:r>
+                <a:rPr lang="en-US" sz="1100" dirty="0" smtClean="0"/>
+                <a:t> BOMD Trajectory 2</a:t>
+              </a:r>
+              <a:endParaRPr lang="en-US" sz="1100" dirty="0"/>
+            </a:p>
+          </p:txBody>
+        </p:sp>
+        <p:sp>
+          <p:nvSpPr>
+            <p:cNvPr id="26" name="Rectangle 25"/>
+            <p:cNvSpPr/>
+            <p:nvPr/>
+          </p:nvSpPr>
+          <p:spPr>
+            <a:xfrm>
+              <a:off x="7471473" y="6067783"/>
+              <a:ext cx="1571946" cy="390634"/>
+            </a:xfrm>
+            <a:prstGeom prst="rect">
+              <a:avLst/>
+            </a:prstGeom>
+            <a:ln>
+              <a:solidFill>
+                <a:schemeClr val="tx1"/>
+              </a:solidFill>
+            </a:ln>
+          </p:spPr>
+          <p:style>
+            <a:lnRef idx="2">
+              <a:schemeClr val="accent6"/>
+            </a:lnRef>
+            <a:fillRef idx="1">
+              <a:schemeClr val="lt1"/>
+            </a:fillRef>
+            <a:effectRef idx="0">
+              <a:schemeClr val="accent6"/>
+            </a:effectRef>
+            <a:fontRef idx="minor">
+              <a:schemeClr val="dk1"/>
+            </a:fontRef>
+          </p:style>
+          <p:txBody>
+            <a:bodyPr rtlCol="0" anchor="ctr"/>
+            <a:lstStyle/>
+            <a:p>
+              <a:pPr algn="ctr"/>
+              <a:r>
+                <a:rPr lang="en-US" sz="1100" dirty="0" smtClean="0"/>
+                <a:t>E</a:t>
+              </a:r>
+              <a:r>
+                <a:rPr lang="en-US" sz="1100" baseline="-25000" dirty="0"/>
+                <a:t>3</a:t>
+              </a:r>
+              <a:r>
+                <a:rPr lang="en-US" sz="1100" baseline="30000" dirty="0" smtClean="0"/>
+                <a:t>field </a:t>
+              </a:r>
+              <a:r>
+                <a:rPr lang="en-US" sz="1100" dirty="0" smtClean="0"/>
+                <a:t> BOMD Trajectory 3</a:t>
+              </a:r>
+              <a:endParaRPr lang="en-US" sz="1100" dirty="0"/>
+            </a:p>
+          </p:txBody>
+        </p:sp>
+        <p:cxnSp>
+          <p:nvCxnSpPr>
+            <p:cNvPr id="27" name="Elbow Connector 26"/>
+            <p:cNvCxnSpPr>
+              <a:stCxn id="9" idx="3"/>
+              <a:endCxn id="18" idx="1"/>
+            </p:cNvCxnSpPr>
+            <p:nvPr/>
+          </p:nvCxnSpPr>
+          <p:spPr>
+            <a:xfrm flipV="1">
+              <a:off x="6813925" y="1780360"/>
+              <a:ext cx="657548" cy="1393317"/>
+            </a:xfrm>
+            <a:prstGeom prst="bentConnector3">
+              <a:avLst/>
+            </a:prstGeom>
+            <a:ln>
+              <a:solidFill>
+                <a:schemeClr val="tx1">
+                  <a:lumMod val="50000"/>
+                  <a:lumOff val="50000"/>
+                </a:schemeClr>
+              </a:solidFill>
+              <a:tailEnd type="triangle"/>
+            </a:ln>
+          </p:spPr>
+          <p:style>
+            <a:lnRef idx="1">
+              <a:schemeClr val="accent1"/>
+            </a:lnRef>
+            <a:fillRef idx="0">
+              <a:schemeClr val="accent1"/>
+            </a:fillRef>
+            <a:effectRef idx="0">
+              <a:schemeClr val="accent1"/>
+            </a:effectRef>
+            <a:fontRef idx="minor">
+              <a:schemeClr val="tx1"/>
+            </a:fontRef>
+          </p:style>
+        </p:cxnSp>
+        <p:cxnSp>
+          <p:nvCxnSpPr>
+            <p:cNvPr id="28" name="Elbow Connector 27"/>
+            <p:cNvCxnSpPr>
+              <a:stCxn id="9" idx="3"/>
+              <a:endCxn id="19" idx="1"/>
+            </p:cNvCxnSpPr>
+            <p:nvPr/>
+          </p:nvCxnSpPr>
+          <p:spPr>
+            <a:xfrm flipV="1">
+              <a:off x="6813925" y="2340799"/>
+              <a:ext cx="657548" cy="832878"/>
+            </a:xfrm>
+            <a:prstGeom prst="bentConnector3">
+              <a:avLst/>
+            </a:prstGeom>
+            <a:ln>
+              <a:solidFill>
+                <a:schemeClr val="tx1">
+                  <a:lumMod val="50000"/>
+                  <a:lumOff val="50000"/>
+                </a:schemeClr>
+              </a:solidFill>
+              <a:tailEnd type="triangle"/>
+            </a:ln>
+          </p:spPr>
+          <p:style>
+            <a:lnRef idx="1">
+              <a:schemeClr val="accent1"/>
+            </a:lnRef>
+            <a:fillRef idx="0">
+              <a:schemeClr val="accent1"/>
+            </a:fillRef>
+            <a:effectRef idx="0">
+              <a:schemeClr val="accent1"/>
+            </a:effectRef>
+            <a:fontRef idx="minor">
+              <a:schemeClr val="tx1"/>
+            </a:fontRef>
+          </p:style>
+        </p:cxnSp>
+        <p:cxnSp>
+          <p:nvCxnSpPr>
+            <p:cNvPr id="29" name="Elbow Connector 28"/>
+            <p:cNvCxnSpPr>
+              <a:stCxn id="9" idx="3"/>
+              <a:endCxn id="20" idx="1"/>
+            </p:cNvCxnSpPr>
+            <p:nvPr/>
+          </p:nvCxnSpPr>
+          <p:spPr>
+            <a:xfrm flipV="1">
+              <a:off x="6813925" y="2901238"/>
+              <a:ext cx="657548" cy="272439"/>
+            </a:xfrm>
+            <a:prstGeom prst="bentConnector3">
+              <a:avLst/>
+            </a:prstGeom>
+            <a:ln>
+              <a:solidFill>
+                <a:schemeClr val="tx1">
+                  <a:lumMod val="50000"/>
+                  <a:lumOff val="50000"/>
+                </a:schemeClr>
+              </a:solidFill>
+              <a:tailEnd type="triangle"/>
+            </a:ln>
+          </p:spPr>
+          <p:style>
+            <a:lnRef idx="1">
+              <a:schemeClr val="accent1"/>
+            </a:lnRef>
+            <a:fillRef idx="0">
+              <a:schemeClr val="accent1"/>
+            </a:fillRef>
+            <a:effectRef idx="0">
+              <a:schemeClr val="accent1"/>
+            </a:effectRef>
+            <a:fontRef idx="minor">
+              <a:schemeClr val="tx1"/>
+            </a:fontRef>
+          </p:style>
+        </p:cxnSp>
+        <p:cxnSp>
+          <p:nvCxnSpPr>
+            <p:cNvPr id="30" name="Elbow Connector 29"/>
+            <p:cNvCxnSpPr>
+              <a:stCxn id="10" idx="3"/>
+              <a:endCxn id="21" idx="1"/>
+            </p:cNvCxnSpPr>
+            <p:nvPr/>
+          </p:nvCxnSpPr>
+          <p:spPr>
+            <a:xfrm flipV="1">
+              <a:off x="6813925" y="3461291"/>
+              <a:ext cx="657548" cy="560054"/>
+            </a:xfrm>
+            <a:prstGeom prst="bentConnector3">
+              <a:avLst/>
+            </a:prstGeom>
+            <a:ln>
+              <a:solidFill>
+                <a:schemeClr val="tx1">
+                  <a:lumMod val="50000"/>
+                  <a:lumOff val="50000"/>
+                </a:schemeClr>
+              </a:solidFill>
+              <a:tailEnd type="triangle"/>
+            </a:ln>
+          </p:spPr>
+          <p:style>
+            <a:lnRef idx="1">
+              <a:schemeClr val="accent1"/>
+            </a:lnRef>
+            <a:fillRef idx="0">
+              <a:schemeClr val="accent1"/>
+            </a:fillRef>
+            <a:effectRef idx="0">
+              <a:schemeClr val="accent1"/>
+            </a:effectRef>
+            <a:fontRef idx="minor">
+              <a:schemeClr val="tx1"/>
+            </a:fontRef>
+          </p:style>
+        </p:cxnSp>
+        <p:cxnSp>
+          <p:nvCxnSpPr>
+            <p:cNvPr id="31" name="Elbow Connector 30"/>
+            <p:cNvCxnSpPr>
+              <a:stCxn id="10" idx="3"/>
+              <a:endCxn id="22" idx="1"/>
+            </p:cNvCxnSpPr>
+            <p:nvPr/>
+          </p:nvCxnSpPr>
+          <p:spPr>
+            <a:xfrm flipV="1">
+              <a:off x="6813925" y="4021344"/>
+              <a:ext cx="657548" cy="1"/>
+            </a:xfrm>
+            <a:prstGeom prst="bentConnector3">
+              <a:avLst/>
+            </a:prstGeom>
+            <a:ln>
+              <a:solidFill>
+                <a:schemeClr val="tx1">
+                  <a:lumMod val="50000"/>
+                  <a:lumOff val="50000"/>
+                </a:schemeClr>
+              </a:solidFill>
+              <a:tailEnd type="triangle"/>
+            </a:ln>
+          </p:spPr>
+          <p:style>
+            <a:lnRef idx="1">
+              <a:schemeClr val="accent1"/>
+            </a:lnRef>
+            <a:fillRef idx="0">
+              <a:schemeClr val="accent1"/>
+            </a:fillRef>
+            <a:effectRef idx="0">
+              <a:schemeClr val="accent1"/>
+            </a:effectRef>
+            <a:fontRef idx="minor">
+              <a:schemeClr val="tx1"/>
+            </a:fontRef>
+          </p:style>
+        </p:cxnSp>
+        <p:cxnSp>
+          <p:nvCxnSpPr>
+            <p:cNvPr id="32" name="Elbow Connector 31"/>
+            <p:cNvCxnSpPr>
+              <a:stCxn id="10" idx="3"/>
+              <a:endCxn id="23" idx="1"/>
+            </p:cNvCxnSpPr>
+            <p:nvPr/>
+          </p:nvCxnSpPr>
+          <p:spPr>
+            <a:xfrm>
+              <a:off x="6813925" y="4021345"/>
+              <a:ext cx="657548" cy="560438"/>
+            </a:xfrm>
+            <a:prstGeom prst="bentConnector3">
+              <a:avLst/>
+            </a:prstGeom>
+            <a:ln>
+              <a:solidFill>
+                <a:schemeClr val="tx1">
+                  <a:lumMod val="50000"/>
+                  <a:lumOff val="50000"/>
+                </a:schemeClr>
+              </a:solidFill>
+              <a:tailEnd type="triangle"/>
+            </a:ln>
+          </p:spPr>
+          <p:style>
+            <a:lnRef idx="1">
+              <a:schemeClr val="accent1"/>
+            </a:lnRef>
+            <a:fillRef idx="0">
+              <a:schemeClr val="accent1"/>
+            </a:fillRef>
+            <a:effectRef idx="0">
+              <a:schemeClr val="accent1"/>
+            </a:effectRef>
+            <a:fontRef idx="minor">
+              <a:schemeClr val="tx1"/>
+            </a:fontRef>
+          </p:style>
+        </p:cxnSp>
+        <p:cxnSp>
+          <p:nvCxnSpPr>
+            <p:cNvPr id="33" name="Elbow Connector 32"/>
+            <p:cNvCxnSpPr>
+              <a:stCxn id="11" idx="3"/>
+              <a:endCxn id="26" idx="1"/>
+            </p:cNvCxnSpPr>
+            <p:nvPr/>
+          </p:nvCxnSpPr>
+          <p:spPr>
+            <a:xfrm>
+              <a:off x="6813925" y="4869012"/>
+              <a:ext cx="657548" cy="1394088"/>
+            </a:xfrm>
+            <a:prstGeom prst="bentConnector3">
+              <a:avLst/>
+            </a:prstGeom>
+            <a:ln>
+              <a:solidFill>
+                <a:schemeClr val="tx1">
+                  <a:lumMod val="50000"/>
+                  <a:lumOff val="50000"/>
+                </a:schemeClr>
+              </a:solidFill>
+            </a:ln>
+          </p:spPr>
+          <p:style>
+            <a:lnRef idx="1">
+              <a:schemeClr val="accent1"/>
+            </a:lnRef>
+            <a:fillRef idx="0">
+              <a:schemeClr val="accent1"/>
+            </a:fillRef>
+            <a:effectRef idx="0">
+              <a:schemeClr val="accent1"/>
+            </a:effectRef>
+            <a:fontRef idx="minor">
+              <a:schemeClr val="tx1"/>
+            </a:fontRef>
+          </p:style>
+        </p:cxnSp>
+        <p:cxnSp>
+          <p:nvCxnSpPr>
+            <p:cNvPr id="34" name="Elbow Connector 33"/>
+            <p:cNvCxnSpPr>
+              <a:stCxn id="11" idx="3"/>
+              <a:endCxn id="26" idx="1"/>
+            </p:cNvCxnSpPr>
+            <p:nvPr/>
+          </p:nvCxnSpPr>
+          <p:spPr>
+            <a:xfrm>
+              <a:off x="6813925" y="4869012"/>
+              <a:ext cx="657548" cy="1394088"/>
+            </a:xfrm>
+            <a:prstGeom prst="bentConnector3">
+              <a:avLst/>
+            </a:prstGeom>
+            <a:ln>
+              <a:solidFill>
+                <a:schemeClr val="tx1">
+                  <a:lumMod val="50000"/>
+                  <a:lumOff val="50000"/>
+                </a:schemeClr>
+              </a:solidFill>
+              <a:tailEnd type="triangle"/>
+            </a:ln>
+          </p:spPr>
+          <p:style>
+            <a:lnRef idx="1">
+              <a:schemeClr val="accent1"/>
+            </a:lnRef>
+            <a:fillRef idx="0">
+              <a:schemeClr val="accent1"/>
+            </a:fillRef>
+            <a:effectRef idx="0">
+              <a:schemeClr val="accent1"/>
+            </a:effectRef>
+            <a:fontRef idx="minor">
+              <a:schemeClr val="tx1"/>
+            </a:fontRef>
+          </p:style>
+        </p:cxnSp>
+        <p:cxnSp>
+          <p:nvCxnSpPr>
+            <p:cNvPr id="35" name="Elbow Connector 34"/>
+            <p:cNvCxnSpPr>
+              <a:stCxn id="11" idx="3"/>
+              <a:endCxn id="25" idx="1"/>
+            </p:cNvCxnSpPr>
+            <p:nvPr/>
+          </p:nvCxnSpPr>
+          <p:spPr>
+            <a:xfrm>
+              <a:off x="6813925" y="4869012"/>
+              <a:ext cx="657548" cy="833649"/>
+            </a:xfrm>
+            <a:prstGeom prst="bentConnector3">
+              <a:avLst/>
+            </a:prstGeom>
+            <a:ln>
+              <a:solidFill>
+                <a:schemeClr val="tx1">
+                  <a:lumMod val="50000"/>
+                  <a:lumOff val="50000"/>
+                </a:schemeClr>
+              </a:solidFill>
+              <a:tailEnd type="triangle"/>
+            </a:ln>
+          </p:spPr>
+          <p:style>
+            <a:lnRef idx="1">
+              <a:schemeClr val="accent1"/>
+            </a:lnRef>
+            <a:fillRef idx="0">
+              <a:schemeClr val="accent1"/>
+            </a:fillRef>
+            <a:effectRef idx="0">
+              <a:schemeClr val="accent1"/>
+            </a:effectRef>
+            <a:fontRef idx="minor">
+              <a:schemeClr val="tx1"/>
+            </a:fontRef>
+          </p:style>
+        </p:cxnSp>
+        <p:cxnSp>
+          <p:nvCxnSpPr>
+            <p:cNvPr id="36" name="Elbow Connector 35"/>
+            <p:cNvCxnSpPr>
+              <a:stCxn id="11" idx="3"/>
+              <a:endCxn id="24" idx="1"/>
+            </p:cNvCxnSpPr>
+            <p:nvPr/>
+          </p:nvCxnSpPr>
+          <p:spPr>
+            <a:xfrm>
+              <a:off x="6813925" y="4869012"/>
+              <a:ext cx="657548" cy="273210"/>
+            </a:xfrm>
+            <a:prstGeom prst="bentConnector3">
+              <a:avLst/>
+            </a:prstGeom>
+            <a:ln>
+              <a:solidFill>
+                <a:schemeClr val="tx1">
+                  <a:lumMod val="50000"/>
+                  <a:lumOff val="50000"/>
+                </a:schemeClr>
+              </a:solidFill>
+              <a:tailEnd type="triangle"/>
+            </a:ln>
+          </p:spPr>
+          <p:style>
+            <a:lnRef idx="1">
+              <a:schemeClr val="accent1"/>
+            </a:lnRef>
+            <a:fillRef idx="0">
+              <a:schemeClr val="accent1"/>
+            </a:fillRef>
+            <a:effectRef idx="0">
+              <a:schemeClr val="accent1"/>
+            </a:effectRef>
+            <a:fontRef idx="minor">
+              <a:schemeClr val="tx1"/>
+            </a:fontRef>
+          </p:style>
+        </p:cxnSp>
+        <p:sp>
+          <p:nvSpPr>
+            <p:cNvPr id="37" name="Right Brace 36"/>
+            <p:cNvSpPr/>
+            <p:nvPr/>
+          </p:nvSpPr>
+          <p:spPr>
+            <a:xfrm rot="16200000">
+              <a:off x="5674091" y="-1874382"/>
+              <a:ext cx="707720" cy="6030935"/>
+            </a:xfrm>
+            <a:prstGeom prst="rightBrace">
+              <a:avLst/>
+            </a:prstGeom>
+            <a:ln>
+              <a:solidFill>
+                <a:schemeClr val="tx1"/>
+              </a:solidFill>
+            </a:ln>
+          </p:spPr>
+          <p:style>
+            <a:lnRef idx="1">
+              <a:schemeClr val="accent1"/>
+            </a:lnRef>
+            <a:fillRef idx="0">
+              <a:schemeClr val="accent1"/>
+            </a:fillRef>
+            <a:effectRef idx="0">
+              <a:schemeClr val="accent1"/>
+            </a:effectRef>
+            <a:fontRef idx="minor">
+              <a:schemeClr val="tx1"/>
+            </a:fontRef>
+          </p:style>
+          <p:txBody>
+            <a:bodyPr rtlCol="0" anchor="ctr"/>
+            <a:lstStyle/>
+            <a:p>
+              <a:pPr algn="ctr"/>
+              <a:endParaRPr lang="en-US" sz="1100">
+                <a:solidFill>
+                  <a:srgbClr val="FF0000"/>
+                </a:solidFill>
+              </a:endParaRPr>
+            </a:p>
+          </p:txBody>
+        </p:sp>
+        <p:sp>
+          <p:nvSpPr>
+            <p:cNvPr id="38" name="Right Brace 37"/>
+            <p:cNvSpPr/>
+            <p:nvPr/>
+          </p:nvSpPr>
+          <p:spPr>
+            <a:xfrm rot="16200000">
+              <a:off x="1574702" y="57162"/>
+              <a:ext cx="707720" cy="2167848"/>
+            </a:xfrm>
+            <a:prstGeom prst="rightBrace">
+              <a:avLst/>
+            </a:prstGeom>
+            <a:ln>
+              <a:solidFill>
+                <a:schemeClr val="tx1"/>
+              </a:solidFill>
+            </a:ln>
+          </p:spPr>
+          <p:style>
+            <a:lnRef idx="1">
+              <a:schemeClr val="accent1"/>
+            </a:lnRef>
+            <a:fillRef idx="0">
+              <a:schemeClr val="accent1"/>
+            </a:fillRef>
+            <a:effectRef idx="0">
+              <a:schemeClr val="accent1"/>
+            </a:effectRef>
+            <a:fontRef idx="minor">
+              <a:schemeClr val="tx1"/>
+            </a:fontRef>
+          </p:style>
+          <p:txBody>
+            <a:bodyPr rtlCol="0" anchor="ctr"/>
+            <a:lstStyle/>
+            <a:p>
+              <a:pPr algn="ctr"/>
+              <a:endParaRPr lang="en-US" sz="1100">
+                <a:solidFill>
+                  <a:srgbClr val="FF0000"/>
+                </a:solidFill>
+              </a:endParaRPr>
+            </a:p>
+          </p:txBody>
+        </p:sp>
+        <p:sp>
+          <p:nvSpPr>
+            <p:cNvPr id="39" name="TextBox 38"/>
+            <p:cNvSpPr txBox="1"/>
+            <p:nvPr/>
+          </p:nvSpPr>
+          <p:spPr>
+            <a:xfrm>
+              <a:off x="4763022" y="1230572"/>
+              <a:ext cx="2438006" cy="300717"/>
+            </a:xfrm>
+            <a:prstGeom prst="rect">
+              <a:avLst/>
+            </a:prstGeom>
+            <a:noFill/>
+          </p:spPr>
+          <p:txBody>
+            <a:bodyPr wrap="none" rtlCol="0">
+              <a:spAutoFit/>
+            </a:bodyPr>
+            <a:lstStyle/>
+            <a:p>
+              <a:r>
+                <a:rPr lang="en-US" sz="1100" dirty="0" smtClean="0"/>
+                <a:t>E-Field Applied in Gaussian</a:t>
+              </a:r>
+              <a:endParaRPr lang="en-US" sz="1100" dirty="0"/>
+            </a:p>
+          </p:txBody>
+        </p:sp>
+        <p:sp>
+          <p:nvSpPr>
+            <p:cNvPr id="40" name="TextBox 39"/>
+            <p:cNvSpPr txBox="1"/>
+            <p:nvPr/>
+          </p:nvSpPr>
+          <p:spPr>
+            <a:xfrm>
+              <a:off x="1360039" y="1227551"/>
+              <a:ext cx="1057382" cy="300717"/>
+            </a:xfrm>
+            <a:prstGeom prst="rect">
+              <a:avLst/>
+            </a:prstGeom>
+            <a:noFill/>
+          </p:spPr>
+          <p:txBody>
+            <a:bodyPr wrap="none" rtlCol="0">
+              <a:spAutoFit/>
+            </a:bodyPr>
+            <a:lstStyle/>
+            <a:p>
+              <a:r>
+                <a:rPr lang="en-US" sz="1100" dirty="0" smtClean="0"/>
+                <a:t>No E-Field</a:t>
+              </a:r>
+              <a:endParaRPr lang="en-US" sz="1100" dirty="0"/>
+            </a:p>
+          </p:txBody>
+        </p:sp>
+        <p:sp>
+          <p:nvSpPr>
+            <p:cNvPr id="41" name="Rectangle 40"/>
+            <p:cNvSpPr/>
+            <p:nvPr/>
+          </p:nvSpPr>
+          <p:spPr>
+            <a:xfrm>
+              <a:off x="9699958" y="1596883"/>
+              <a:ext cx="1571946" cy="1499672"/>
+            </a:xfrm>
+            <a:prstGeom prst="rect">
+              <a:avLst/>
+            </a:prstGeom>
+            <a:ln>
+              <a:solidFill>
+                <a:schemeClr val="tx1"/>
+              </a:solidFill>
+            </a:ln>
+          </p:spPr>
+          <p:style>
+            <a:lnRef idx="2">
+              <a:schemeClr val="accent6"/>
+            </a:lnRef>
+            <a:fillRef idx="1">
+              <a:schemeClr val="lt1"/>
+            </a:fillRef>
+            <a:effectRef idx="0">
+              <a:schemeClr val="accent6"/>
+            </a:effectRef>
+            <a:fontRef idx="minor">
+              <a:schemeClr val="dk1"/>
+            </a:fontRef>
+          </p:style>
+          <p:txBody>
+            <a:bodyPr rtlCol="0" anchor="ctr"/>
+            <a:lstStyle/>
+            <a:p>
+              <a:r>
+                <a:rPr lang="en-US" sz="1100" dirty="0" smtClean="0"/>
+                <a:t>E</a:t>
+              </a:r>
+              <a:r>
+                <a:rPr lang="en-US" sz="1100" baseline="-25000" dirty="0" smtClean="0"/>
+                <a:t>1</a:t>
+              </a:r>
+              <a:r>
+                <a:rPr lang="en-US" sz="1100" baseline="30000" dirty="0" smtClean="0"/>
+                <a:t>field</a:t>
+              </a:r>
+              <a:r>
+                <a:rPr lang="en-US" sz="1100" dirty="0" smtClean="0"/>
+                <a:t> IR Spectrum</a:t>
+              </a:r>
+              <a:endParaRPr lang="en-US" sz="1100" dirty="0"/>
+            </a:p>
+          </p:txBody>
+        </p:sp>
+        <p:sp>
+          <p:nvSpPr>
+            <p:cNvPr id="42" name="Rectangle 41"/>
+            <p:cNvSpPr/>
+            <p:nvPr/>
+          </p:nvSpPr>
+          <p:spPr>
+            <a:xfrm>
+              <a:off x="9699958" y="3265974"/>
+              <a:ext cx="1571946" cy="1511126"/>
+            </a:xfrm>
+            <a:prstGeom prst="rect">
+              <a:avLst/>
+            </a:prstGeom>
+            <a:ln>
+              <a:solidFill>
+                <a:schemeClr val="tx1"/>
+              </a:solidFill>
+            </a:ln>
+          </p:spPr>
+          <p:style>
+            <a:lnRef idx="2">
+              <a:schemeClr val="accent6"/>
+            </a:lnRef>
+            <a:fillRef idx="1">
+              <a:schemeClr val="lt1"/>
+            </a:fillRef>
+            <a:effectRef idx="0">
+              <a:schemeClr val="accent6"/>
+            </a:effectRef>
+            <a:fontRef idx="minor">
+              <a:schemeClr val="dk1"/>
+            </a:fontRef>
+          </p:style>
+          <p:txBody>
+            <a:bodyPr rtlCol="0" anchor="ctr"/>
+            <a:lstStyle/>
+            <a:p>
+              <a:r>
+                <a:rPr lang="en-US" sz="1100" dirty="0" smtClean="0"/>
+                <a:t>E</a:t>
+              </a:r>
+              <a:r>
+                <a:rPr lang="en-US" sz="1100" baseline="-25000" dirty="0"/>
+                <a:t>2</a:t>
+              </a:r>
+              <a:r>
+                <a:rPr lang="en-US" sz="1100" baseline="30000" dirty="0" smtClean="0"/>
+                <a:t>field</a:t>
+              </a:r>
+              <a:r>
+                <a:rPr lang="en-US" sz="1100" dirty="0" smtClean="0"/>
+                <a:t> IR Spectrum</a:t>
+              </a:r>
+              <a:endParaRPr lang="en-US" sz="1100" dirty="0"/>
+            </a:p>
+          </p:txBody>
+        </p:sp>
+        <p:sp>
+          <p:nvSpPr>
+            <p:cNvPr id="43" name="Rectangle 42"/>
+            <p:cNvSpPr/>
+            <p:nvPr/>
+          </p:nvSpPr>
+          <p:spPr>
+            <a:xfrm>
+              <a:off x="9699958" y="4958745"/>
+              <a:ext cx="1571946" cy="1499672"/>
+            </a:xfrm>
+            <a:prstGeom prst="rect">
+              <a:avLst/>
+            </a:prstGeom>
+            <a:ln>
+              <a:solidFill>
+                <a:schemeClr val="tx1"/>
+              </a:solidFill>
+            </a:ln>
+          </p:spPr>
+          <p:style>
+            <a:lnRef idx="2">
+              <a:schemeClr val="accent6"/>
+            </a:lnRef>
+            <a:fillRef idx="1">
+              <a:schemeClr val="lt1"/>
+            </a:fillRef>
+            <a:effectRef idx="0">
+              <a:schemeClr val="accent6"/>
+            </a:effectRef>
+            <a:fontRef idx="minor">
+              <a:schemeClr val="dk1"/>
+            </a:fontRef>
+          </p:style>
+          <p:txBody>
+            <a:bodyPr rtlCol="0" anchor="ctr"/>
+            <a:lstStyle/>
+            <a:p>
+              <a:r>
+                <a:rPr lang="en-US" sz="1100" dirty="0" smtClean="0"/>
+                <a:t>E</a:t>
+              </a:r>
+              <a:r>
+                <a:rPr lang="en-US" sz="1100" baseline="-25000" dirty="0"/>
+                <a:t>3</a:t>
+              </a:r>
+              <a:r>
+                <a:rPr lang="en-US" sz="1100" baseline="30000" dirty="0" smtClean="0"/>
+                <a:t>field</a:t>
+              </a:r>
+              <a:r>
+                <a:rPr lang="en-US" sz="1100" dirty="0" smtClean="0"/>
+                <a:t> IR Spectrum</a:t>
+              </a:r>
+              <a:endParaRPr lang="en-US" sz="1100" dirty="0"/>
+            </a:p>
+          </p:txBody>
+        </p:sp>
+        <p:cxnSp>
+          <p:nvCxnSpPr>
+            <p:cNvPr id="44" name="Elbow Connector 43"/>
+            <p:cNvCxnSpPr>
+              <a:stCxn id="18" idx="3"/>
+              <a:endCxn id="41" idx="1"/>
+            </p:cNvCxnSpPr>
+            <p:nvPr/>
+          </p:nvCxnSpPr>
+          <p:spPr>
+            <a:xfrm>
+              <a:off x="9043419" y="1780360"/>
+              <a:ext cx="656539" cy="566359"/>
+            </a:xfrm>
+            <a:prstGeom prst="bentConnector3">
+              <a:avLst/>
+            </a:prstGeom>
+            <a:ln>
+              <a:solidFill>
+                <a:schemeClr val="tx1">
+                  <a:lumMod val="50000"/>
+                  <a:lumOff val="50000"/>
+                </a:schemeClr>
+              </a:solidFill>
+              <a:tailEnd type="triangle"/>
+            </a:ln>
+          </p:spPr>
+          <p:style>
+            <a:lnRef idx="1">
+              <a:schemeClr val="accent1"/>
+            </a:lnRef>
+            <a:fillRef idx="0">
+              <a:schemeClr val="accent1"/>
+            </a:fillRef>
+            <a:effectRef idx="0">
+              <a:schemeClr val="accent1"/>
+            </a:effectRef>
+            <a:fontRef idx="minor">
+              <a:schemeClr val="tx1"/>
+            </a:fontRef>
+          </p:style>
+        </p:cxnSp>
+        <p:cxnSp>
+          <p:nvCxnSpPr>
+            <p:cNvPr id="45" name="Elbow Connector 44"/>
+            <p:cNvCxnSpPr>
+              <a:stCxn id="19" idx="3"/>
+              <a:endCxn id="41" idx="1"/>
+            </p:cNvCxnSpPr>
+            <p:nvPr/>
+          </p:nvCxnSpPr>
+          <p:spPr>
+            <a:xfrm>
+              <a:off x="9043419" y="2340799"/>
+              <a:ext cx="656539" cy="5920"/>
+            </a:xfrm>
+            <a:prstGeom prst="bentConnector3">
+              <a:avLst/>
+            </a:prstGeom>
+            <a:ln>
+              <a:solidFill>
+                <a:schemeClr val="tx1">
+                  <a:lumMod val="50000"/>
+                  <a:lumOff val="50000"/>
+                </a:schemeClr>
+              </a:solidFill>
+              <a:tailEnd type="triangle"/>
+            </a:ln>
+          </p:spPr>
+          <p:style>
+            <a:lnRef idx="1">
+              <a:schemeClr val="accent1"/>
+            </a:lnRef>
+            <a:fillRef idx="0">
+              <a:schemeClr val="accent1"/>
+            </a:fillRef>
+            <a:effectRef idx="0">
+              <a:schemeClr val="accent1"/>
+            </a:effectRef>
+            <a:fontRef idx="minor">
+              <a:schemeClr val="tx1"/>
+            </a:fontRef>
+          </p:style>
+        </p:cxnSp>
+        <p:cxnSp>
+          <p:nvCxnSpPr>
+            <p:cNvPr id="46" name="Elbow Connector 45"/>
+            <p:cNvCxnSpPr>
+              <a:stCxn id="20" idx="3"/>
+              <a:endCxn id="41" idx="1"/>
+            </p:cNvCxnSpPr>
+            <p:nvPr/>
+          </p:nvCxnSpPr>
+          <p:spPr>
+            <a:xfrm flipV="1">
+              <a:off x="9043419" y="2346719"/>
+              <a:ext cx="656539" cy="554519"/>
+            </a:xfrm>
+            <a:prstGeom prst="bentConnector3">
+              <a:avLst/>
+            </a:prstGeom>
+            <a:ln>
+              <a:solidFill>
+                <a:schemeClr val="tx1">
+                  <a:lumMod val="50000"/>
+                  <a:lumOff val="50000"/>
+                </a:schemeClr>
+              </a:solidFill>
+              <a:tailEnd type="triangle"/>
+            </a:ln>
+          </p:spPr>
+          <p:style>
+            <a:lnRef idx="1">
+              <a:schemeClr val="accent1"/>
+            </a:lnRef>
+            <a:fillRef idx="0">
+              <a:schemeClr val="accent1"/>
+            </a:fillRef>
+            <a:effectRef idx="0">
+              <a:schemeClr val="accent1"/>
+            </a:effectRef>
+            <a:fontRef idx="minor">
+              <a:schemeClr val="tx1"/>
+            </a:fontRef>
+          </p:style>
+        </p:cxnSp>
+        <p:cxnSp>
+          <p:nvCxnSpPr>
+            <p:cNvPr id="47" name="Elbow Connector 46"/>
+            <p:cNvCxnSpPr>
+              <a:stCxn id="21" idx="3"/>
+            </p:cNvCxnSpPr>
+            <p:nvPr/>
+          </p:nvCxnSpPr>
+          <p:spPr>
+            <a:xfrm>
+              <a:off x="9043419" y="3461291"/>
+              <a:ext cx="656539" cy="557093"/>
+            </a:xfrm>
+            <a:prstGeom prst="bentConnector3">
+              <a:avLst/>
+            </a:prstGeom>
+            <a:ln>
+              <a:solidFill>
+                <a:schemeClr val="tx1">
+                  <a:lumMod val="50000"/>
+                  <a:lumOff val="50000"/>
+                </a:schemeClr>
+              </a:solidFill>
+              <a:tailEnd type="triangle"/>
+            </a:ln>
+          </p:spPr>
+          <p:style>
+            <a:lnRef idx="1">
+              <a:schemeClr val="accent1"/>
+            </a:lnRef>
+            <a:fillRef idx="0">
+              <a:schemeClr val="accent1"/>
+            </a:fillRef>
+            <a:effectRef idx="0">
+              <a:schemeClr val="accent1"/>
+            </a:effectRef>
+            <a:fontRef idx="minor">
+              <a:schemeClr val="tx1"/>
+            </a:fontRef>
+          </p:style>
+        </p:cxnSp>
+        <p:cxnSp>
+          <p:nvCxnSpPr>
+            <p:cNvPr id="48" name="Elbow Connector 47"/>
+            <p:cNvCxnSpPr>
+              <a:stCxn id="23" idx="3"/>
+              <a:endCxn id="42" idx="1"/>
+            </p:cNvCxnSpPr>
+            <p:nvPr/>
+          </p:nvCxnSpPr>
+          <p:spPr>
+            <a:xfrm flipV="1">
+              <a:off x="9043419" y="4021537"/>
+              <a:ext cx="656539" cy="560246"/>
+            </a:xfrm>
+            <a:prstGeom prst="bentConnector3">
+              <a:avLst/>
+            </a:prstGeom>
+            <a:ln>
+              <a:solidFill>
+                <a:schemeClr val="tx1">
+                  <a:lumMod val="50000"/>
+                  <a:lumOff val="50000"/>
+                </a:schemeClr>
+              </a:solidFill>
+              <a:tailEnd type="triangle"/>
+            </a:ln>
+          </p:spPr>
+          <p:style>
+            <a:lnRef idx="1">
+              <a:schemeClr val="accent1"/>
+            </a:lnRef>
+            <a:fillRef idx="0">
+              <a:schemeClr val="accent1"/>
+            </a:fillRef>
+            <a:effectRef idx="0">
+              <a:schemeClr val="accent1"/>
+            </a:effectRef>
+            <a:fontRef idx="minor">
+              <a:schemeClr val="tx1"/>
+            </a:fontRef>
+          </p:style>
+        </p:cxnSp>
+        <p:cxnSp>
+          <p:nvCxnSpPr>
+            <p:cNvPr id="49" name="Elbow Connector 48"/>
+            <p:cNvCxnSpPr>
+              <a:stCxn id="22" idx="3"/>
+              <a:endCxn id="42" idx="1"/>
+            </p:cNvCxnSpPr>
+            <p:nvPr/>
+          </p:nvCxnSpPr>
+          <p:spPr>
+            <a:xfrm>
+              <a:off x="9043419" y="4021344"/>
+              <a:ext cx="656539" cy="193"/>
+            </a:xfrm>
+            <a:prstGeom prst="bentConnector3">
+              <a:avLst/>
+            </a:prstGeom>
+            <a:ln>
+              <a:solidFill>
+                <a:schemeClr val="tx1">
+                  <a:lumMod val="50000"/>
+                  <a:lumOff val="50000"/>
+                </a:schemeClr>
+              </a:solidFill>
+              <a:tailEnd type="triangle"/>
+            </a:ln>
+          </p:spPr>
+          <p:style>
+            <a:lnRef idx="1">
+              <a:schemeClr val="accent1"/>
+            </a:lnRef>
+            <a:fillRef idx="0">
+              <a:schemeClr val="accent1"/>
+            </a:fillRef>
+            <a:effectRef idx="0">
+              <a:schemeClr val="accent1"/>
+            </a:effectRef>
+            <a:fontRef idx="minor">
+              <a:schemeClr val="tx1"/>
+            </a:fontRef>
+          </p:style>
+        </p:cxnSp>
+        <p:cxnSp>
+          <p:nvCxnSpPr>
+            <p:cNvPr id="50" name="Elbow Connector 49"/>
+            <p:cNvCxnSpPr>
+              <a:stCxn id="24" idx="3"/>
+              <a:endCxn id="43" idx="1"/>
+            </p:cNvCxnSpPr>
+            <p:nvPr/>
+          </p:nvCxnSpPr>
+          <p:spPr>
+            <a:xfrm>
+              <a:off x="9043419" y="5142222"/>
+              <a:ext cx="656539" cy="566359"/>
+            </a:xfrm>
+            <a:prstGeom prst="bentConnector3">
+              <a:avLst/>
+            </a:prstGeom>
+            <a:ln>
+              <a:solidFill>
+                <a:schemeClr val="tx1">
+                  <a:lumMod val="50000"/>
+                  <a:lumOff val="50000"/>
+                </a:schemeClr>
+              </a:solidFill>
+              <a:tailEnd type="triangle"/>
+            </a:ln>
+          </p:spPr>
+          <p:style>
+            <a:lnRef idx="1">
+              <a:schemeClr val="accent1"/>
+            </a:lnRef>
+            <a:fillRef idx="0">
+              <a:schemeClr val="accent1"/>
+            </a:fillRef>
+            <a:effectRef idx="0">
+              <a:schemeClr val="accent1"/>
+            </a:effectRef>
+            <a:fontRef idx="minor">
+              <a:schemeClr val="tx1"/>
+            </a:fontRef>
+          </p:style>
+        </p:cxnSp>
+        <p:cxnSp>
+          <p:nvCxnSpPr>
+            <p:cNvPr id="51" name="Elbow Connector 50"/>
+            <p:cNvCxnSpPr>
+              <a:stCxn id="26" idx="3"/>
+              <a:endCxn id="43" idx="1"/>
+            </p:cNvCxnSpPr>
+            <p:nvPr/>
+          </p:nvCxnSpPr>
+          <p:spPr>
+            <a:xfrm flipV="1">
+              <a:off x="9043419" y="5708581"/>
+              <a:ext cx="656539" cy="554519"/>
+            </a:xfrm>
+            <a:prstGeom prst="bentConnector3">
+              <a:avLst/>
+            </a:prstGeom>
+            <a:ln>
+              <a:solidFill>
+                <a:schemeClr val="tx1">
+                  <a:lumMod val="50000"/>
+                  <a:lumOff val="50000"/>
+                </a:schemeClr>
+              </a:solidFill>
+              <a:tailEnd type="triangle"/>
+            </a:ln>
+          </p:spPr>
+          <p:style>
+            <a:lnRef idx="1">
+              <a:schemeClr val="accent1"/>
+            </a:lnRef>
+            <a:fillRef idx="0">
+              <a:schemeClr val="accent1"/>
+            </a:fillRef>
+            <a:effectRef idx="0">
+              <a:schemeClr val="accent1"/>
+            </a:effectRef>
+            <a:fontRef idx="minor">
+              <a:schemeClr val="tx1"/>
+            </a:fontRef>
+          </p:style>
+        </p:cxnSp>
+        <p:cxnSp>
+          <p:nvCxnSpPr>
+            <p:cNvPr id="52" name="Elbow Connector 51"/>
+            <p:cNvCxnSpPr>
+              <a:stCxn id="25" idx="3"/>
+              <a:endCxn id="43" idx="1"/>
+            </p:cNvCxnSpPr>
+            <p:nvPr/>
+          </p:nvCxnSpPr>
+          <p:spPr>
+            <a:xfrm>
+              <a:off x="9043419" y="5702661"/>
+              <a:ext cx="656539" cy="5920"/>
+            </a:xfrm>
+            <a:prstGeom prst="bentConnector3">
+              <a:avLst/>
+            </a:prstGeom>
+            <a:ln>
+              <a:solidFill>
+                <a:schemeClr val="tx1">
+                  <a:lumMod val="50000"/>
+                  <a:lumOff val="50000"/>
+                </a:schemeClr>
+              </a:solidFill>
+              <a:tailEnd type="triangle"/>
+            </a:ln>
+          </p:spPr>
+          <p:style>
+            <a:lnRef idx="1">
+              <a:schemeClr val="accent1"/>
+            </a:lnRef>
+            <a:fillRef idx="0">
+              <a:schemeClr val="accent1"/>
+            </a:fillRef>
+            <a:effectRef idx="0">
+              <a:schemeClr val="accent1"/>
+            </a:effectRef>
+            <a:fontRef idx="minor">
+              <a:schemeClr val="tx1"/>
+            </a:fontRef>
+          </p:style>
+        </p:cxnSp>
+      </p:grpSp>
     </p:spTree>
     <p:extLst>
       <p:ext uri="{BB962C8B-B14F-4D97-AF65-F5344CB8AC3E}">

</xml_diff>

<commit_message>
Added title and some formatting changes to BOMD Scheme slide.  Yay!
</commit_message>
<xml_diff>
--- a/565Presentation.pptx
+++ b/565Presentation.pptx
@@ -116,6 +116,22 @@
       </a:defRPr>
     </a:lvl9pPr>
   </p:defaultTextStyle>
+  <p:extLst>
+    <p:ext uri="{EFAFB233-063F-42B5-8137-9DF3F51BA10A}">
+      <p15:sldGuideLst xmlns:p15="http://schemas.microsoft.com/office/powerpoint/2012/main">
+        <p15:guide id="1" orient="horz" pos="2160">
+          <p15:clr>
+            <a:srgbClr val="A4A3A4"/>
+          </p15:clr>
+        </p15:guide>
+        <p15:guide id="2" pos="2880">
+          <p15:clr>
+            <a:srgbClr val="A4A3A4"/>
+          </p15:clr>
+        </p15:guide>
+      </p15:sldGuideLst>
+    </p:ext>
+  </p:extLst>
 </p:presentation>
 </file>
 
@@ -4592,16 +4608,21 @@
             <p:ph type="title"/>
           </p:nvPr>
         </p:nvSpPr>
-        <p:spPr/>
+        <p:spPr>
+          <a:xfrm>
+            <a:off x="436924" y="264848"/>
+            <a:ext cx="8042276" cy="898949"/>
+          </a:xfrm>
+        </p:spPr>
         <p:txBody>
           <a:bodyPr/>
           <a:lstStyle/>
           <a:p>
             <a:r>
-              <a:rPr lang="en-US" dirty="0" smtClean="0"/>
-              <a:t>BOMD Flowchart</a:t>
-            </a:r>
-            <a:endParaRPr lang="en-US" dirty="0"/>
+              <a:rPr lang="en-US" sz="2800" dirty="0" smtClean="0"/>
+              <a:t>IR Spectra from BOMD in Electric Field Calculation Scheme</a:t>
+            </a:r>
+            <a:endParaRPr lang="en-US" sz="2800" dirty="0"/>
           </a:p>
         </p:txBody>
       </p:sp>
@@ -6432,23 +6453,24 @@
             <a:bodyPr rtlCol="0" anchor="ctr"/>
             <a:lstStyle/>
             <a:p>
-              <a:r>
-                <a:rPr lang="en-US" sz="1100" dirty="0" smtClean="0"/>
+              <a:pPr algn="ctr"/>
+              <a:r>
+                <a:rPr lang="en-US" sz="1400" dirty="0" smtClean="0"/>
                 <a:t>E</a:t>
               </a:r>
               <a:r>
-                <a:rPr lang="en-US" sz="1100" baseline="-25000" dirty="0" smtClean="0"/>
+                <a:rPr lang="en-US" sz="1400" baseline="-25000" dirty="0" smtClean="0"/>
                 <a:t>1</a:t>
               </a:r>
               <a:r>
-                <a:rPr lang="en-US" sz="1100" baseline="30000" dirty="0" smtClean="0"/>
+                <a:rPr lang="en-US" sz="1400" baseline="30000" dirty="0" smtClean="0"/>
                 <a:t>field</a:t>
               </a:r>
               <a:r>
-                <a:rPr lang="en-US" sz="1100" dirty="0" smtClean="0"/>
+                <a:rPr lang="en-US" sz="1400" dirty="0" smtClean="0"/>
                 <a:t> IR Spectrum</a:t>
               </a:r>
-              <a:endParaRPr lang="en-US" sz="1100" dirty="0"/>
+              <a:endParaRPr lang="en-US" sz="1400" dirty="0"/>
             </a:p>
           </p:txBody>
         </p:sp>
@@ -6490,23 +6512,24 @@
             <a:bodyPr rtlCol="0" anchor="ctr"/>
             <a:lstStyle/>
             <a:p>
-              <a:r>
-                <a:rPr lang="en-US" sz="1100" dirty="0" smtClean="0"/>
+              <a:pPr algn="ctr"/>
+              <a:r>
+                <a:rPr lang="en-US" sz="1400" dirty="0" smtClean="0"/>
                 <a:t>E</a:t>
               </a:r>
               <a:r>
-                <a:rPr lang="en-US" sz="1100" baseline="-25000" dirty="0"/>
+                <a:rPr lang="en-US" sz="1400" baseline="-25000" dirty="0"/>
                 <a:t>2</a:t>
               </a:r>
               <a:r>
-                <a:rPr lang="en-US" sz="1100" baseline="30000" dirty="0" smtClean="0"/>
+                <a:rPr lang="en-US" sz="1400" baseline="30000" dirty="0" smtClean="0"/>
                 <a:t>field</a:t>
               </a:r>
               <a:r>
-                <a:rPr lang="en-US" sz="1100" dirty="0" smtClean="0"/>
+                <a:rPr lang="en-US" sz="1400" dirty="0" smtClean="0"/>
                 <a:t> IR Spectrum</a:t>
               </a:r>
-              <a:endParaRPr lang="en-US" sz="1100" dirty="0"/>
+              <a:endParaRPr lang="en-US" sz="1400" dirty="0"/>
             </a:p>
           </p:txBody>
         </p:sp>
@@ -6548,23 +6571,24 @@
             <a:bodyPr rtlCol="0" anchor="ctr"/>
             <a:lstStyle/>
             <a:p>
-              <a:r>
-                <a:rPr lang="en-US" sz="1100" dirty="0" smtClean="0"/>
+              <a:pPr algn="ctr"/>
+              <a:r>
+                <a:rPr lang="en-US" sz="1400" dirty="0" smtClean="0"/>
                 <a:t>E</a:t>
               </a:r>
               <a:r>
-                <a:rPr lang="en-US" sz="1100" baseline="-25000" dirty="0"/>
+                <a:rPr lang="en-US" sz="1400" baseline="-25000" dirty="0"/>
                 <a:t>3</a:t>
               </a:r>
               <a:r>
-                <a:rPr lang="en-US" sz="1100" baseline="30000" dirty="0" smtClean="0"/>
+                <a:rPr lang="en-US" sz="1400" baseline="30000" dirty="0" smtClean="0"/>
                 <a:t>field</a:t>
               </a:r>
               <a:r>
-                <a:rPr lang="en-US" sz="1100" dirty="0" smtClean="0"/>
+                <a:rPr lang="en-US" sz="1400" dirty="0" smtClean="0"/>
                 <a:t> IR Spectrum</a:t>
               </a:r>
-              <a:endParaRPr lang="en-US" sz="1100" dirty="0"/>
+              <a:endParaRPr lang="en-US" sz="1400" dirty="0"/>
             </a:p>
           </p:txBody>
         </p:sp>

</xml_diff>

<commit_message>
another test of git/ppt friendliness
</commit_message>
<xml_diff>
--- a/565Presentation.pptx
+++ b/565Presentation.pptx
@@ -4116,6 +4116,14 @@
           <a:bodyPr/>
           <a:lstStyle/>
           <a:p>
+            <a:r>
+              <a:rPr lang="en-US" dirty="0" smtClean="0"/>
+              <a:t>Emily will write slides </a:t>
+            </a:r>
+            <a:r>
+              <a:rPr lang="en-US" smtClean="0"/>
+              <a:t>for this part!</a:t>
+            </a:r>
             <a:endParaRPr lang="en-US" dirty="0"/>
           </a:p>
         </p:txBody>

</xml_diff>

<commit_message>
fixed some formatting and stuff.
</commit_message>
<xml_diff>
--- a/565Presentation.pptx
+++ b/565Presentation.pptx
@@ -116,6 +116,22 @@
       </a:defRPr>
     </a:lvl9pPr>
   </p:defaultTextStyle>
+  <p:extLst>
+    <p:ext uri="{EFAFB233-063F-42B5-8137-9DF3F51BA10A}">
+      <p15:sldGuideLst xmlns:p15="http://schemas.microsoft.com/office/powerpoint/2012/main">
+        <p15:guide id="1" orient="horz" pos="2160">
+          <p15:clr>
+            <a:srgbClr val="A4A3A4"/>
+          </p15:clr>
+        </p15:guide>
+        <p15:guide id="2" pos="2880">
+          <p15:clr>
+            <a:srgbClr val="A4A3A4"/>
+          </p15:clr>
+        </p15:guide>
+      </p15:sldGuideLst>
+    </p:ext>
+  </p:extLst>
 </p:presentation>
 </file>
 
@@ -4556,7 +4572,19 @@
           <a:bodyPr/>
           <a:lstStyle/>
           <a:p>
-            <a:endParaRPr lang="en-US"/>
+            <a:r>
+              <a:rPr lang="en-US" dirty="0" err="1" smtClean="0"/>
+              <a:t>I’mma</a:t>
+            </a:r>
+            <a:r>
+              <a:rPr lang="en-US" dirty="0" smtClean="0"/>
+              <a:t> put the process in broad strokes for BOMD set up and job submission in Gaussian here</a:t>
+            </a:r>
+            <a:r>
+              <a:rPr lang="is-IS" dirty="0" smtClean="0"/>
+              <a:t>… sometime... (Jay)</a:t>
+            </a:r>
+            <a:endParaRPr lang="en-US" dirty="0"/>
           </a:p>
         </p:txBody>
       </p:sp>
@@ -5113,6 +5141,8 @@
                   <a:lumOff val="50000"/>
                 </a:schemeClr>
               </a:solidFill>
+              <a:headEnd type="none"/>
+              <a:tailEnd type="triangle"/>
             </a:ln>
           </p:spPr>
           <p:style>
@@ -6440,23 +6470,24 @@
             <a:bodyPr rtlCol="0" anchor="ctr"/>
             <a:lstStyle/>
             <a:p>
-              <a:r>
-                <a:rPr lang="en-US" sz="1100" dirty="0" smtClean="0"/>
+              <a:pPr algn="ctr"/>
+              <a:r>
+                <a:rPr lang="en-US" sz="1400" dirty="0" smtClean="0"/>
                 <a:t>E</a:t>
               </a:r>
               <a:r>
-                <a:rPr lang="en-US" sz="1100" baseline="-25000" dirty="0" smtClean="0"/>
+                <a:rPr lang="en-US" sz="1400" baseline="-25000" dirty="0" smtClean="0"/>
                 <a:t>1</a:t>
               </a:r>
               <a:r>
-                <a:rPr lang="en-US" sz="1100" baseline="30000" dirty="0" smtClean="0"/>
+                <a:rPr lang="en-US" sz="1400" baseline="30000" dirty="0" smtClean="0"/>
                 <a:t>field</a:t>
               </a:r>
               <a:r>
-                <a:rPr lang="en-US" sz="1100" dirty="0" smtClean="0"/>
+                <a:rPr lang="en-US" sz="1400" dirty="0" smtClean="0"/>
                 <a:t> IR Spectrum</a:t>
               </a:r>
-              <a:endParaRPr lang="en-US" sz="1100" dirty="0"/>
+              <a:endParaRPr lang="en-US" sz="1400" dirty="0"/>
             </a:p>
           </p:txBody>
         </p:sp>
@@ -6498,23 +6529,24 @@
             <a:bodyPr rtlCol="0" anchor="ctr"/>
             <a:lstStyle/>
             <a:p>
-              <a:r>
-                <a:rPr lang="en-US" sz="1100" dirty="0" smtClean="0"/>
+              <a:pPr algn="ctr"/>
+              <a:r>
+                <a:rPr lang="en-US" sz="1400" dirty="0" smtClean="0"/>
                 <a:t>E</a:t>
               </a:r>
               <a:r>
-                <a:rPr lang="en-US" sz="1100" baseline="-25000" dirty="0"/>
+                <a:rPr lang="en-US" sz="1400" baseline="-25000" dirty="0"/>
                 <a:t>2</a:t>
               </a:r>
               <a:r>
-                <a:rPr lang="en-US" sz="1100" baseline="30000" dirty="0" smtClean="0"/>
+                <a:rPr lang="en-US" sz="1400" baseline="30000" dirty="0" smtClean="0"/>
                 <a:t>field</a:t>
               </a:r>
               <a:r>
-                <a:rPr lang="en-US" sz="1100" dirty="0" smtClean="0"/>
+                <a:rPr lang="en-US" sz="1400" dirty="0" smtClean="0"/>
                 <a:t> IR Spectrum</a:t>
               </a:r>
-              <a:endParaRPr lang="en-US" sz="1100" dirty="0"/>
+              <a:endParaRPr lang="en-US" sz="1400" dirty="0"/>
             </a:p>
           </p:txBody>
         </p:sp>
@@ -6556,23 +6588,24 @@
             <a:bodyPr rtlCol="0" anchor="ctr"/>
             <a:lstStyle/>
             <a:p>
-              <a:r>
-                <a:rPr lang="en-US" sz="1100" dirty="0" smtClean="0"/>
+              <a:pPr algn="ctr"/>
+              <a:r>
+                <a:rPr lang="en-US" sz="1400" dirty="0" smtClean="0"/>
                 <a:t>E</a:t>
               </a:r>
               <a:r>
-                <a:rPr lang="en-US" sz="1100" baseline="-25000" dirty="0"/>
+                <a:rPr lang="en-US" sz="1400" baseline="-25000" dirty="0"/>
                 <a:t>3</a:t>
               </a:r>
               <a:r>
-                <a:rPr lang="en-US" sz="1100" baseline="30000" dirty="0" smtClean="0"/>
+                <a:rPr lang="en-US" sz="1400" baseline="30000" dirty="0" smtClean="0"/>
                 <a:t>field</a:t>
               </a:r>
               <a:r>
-                <a:rPr lang="en-US" sz="1100" dirty="0" smtClean="0"/>
+                <a:rPr lang="en-US" sz="1400" dirty="0" smtClean="0"/>
                 <a:t> IR Spectrum</a:t>
               </a:r>
-              <a:endParaRPr lang="en-US" sz="1100" dirty="0"/>
+              <a:endParaRPr lang="en-US" sz="1400" dirty="0"/>
             </a:p>
           </p:txBody>
         </p:sp>

</xml_diff>

<commit_message>
added some slides and changed the title a little bit.
</commit_message>
<xml_diff>
--- a/565Presentation.pptx
+++ b/565Presentation.pptx
@@ -7,17 +7,20 @@
   <p:sldIdLst>
     <p:sldId id="256" r:id="rId2"/>
     <p:sldId id="257" r:id="rId3"/>
-    <p:sldId id="258" r:id="rId4"/>
-    <p:sldId id="259" r:id="rId5"/>
-    <p:sldId id="260" r:id="rId6"/>
-    <p:sldId id="261" r:id="rId7"/>
-    <p:sldId id="262" r:id="rId8"/>
-    <p:sldId id="263" r:id="rId9"/>
-    <p:sldId id="264" r:id="rId10"/>
-    <p:sldId id="265" r:id="rId11"/>
-    <p:sldId id="266" r:id="rId12"/>
-    <p:sldId id="267" r:id="rId13"/>
-    <p:sldId id="268" r:id="rId14"/>
+    <p:sldId id="273" r:id="rId4"/>
+    <p:sldId id="258" r:id="rId5"/>
+    <p:sldId id="259" r:id="rId6"/>
+    <p:sldId id="270" r:id="rId7"/>
+    <p:sldId id="272" r:id="rId8"/>
+    <p:sldId id="260" r:id="rId9"/>
+    <p:sldId id="261" r:id="rId10"/>
+    <p:sldId id="262" r:id="rId11"/>
+    <p:sldId id="263" r:id="rId12"/>
+    <p:sldId id="264" r:id="rId13"/>
+    <p:sldId id="265" r:id="rId14"/>
+    <p:sldId id="266" r:id="rId15"/>
+    <p:sldId id="267" r:id="rId16"/>
+    <p:sldId id="268" r:id="rId17"/>
   </p:sldIdLst>
   <p:sldSz cx="9144000" cy="6858000" type="screen4x3"/>
   <p:notesSz cx="6858000" cy="9144000"/>
@@ -418,7 +421,7 @@
           <a:p>
             <a:fld id="{57538935-E887-7942-8C81-098190EB1550}" type="datetimeFigureOut">
               <a:rPr lang="en-US" smtClean="0"/>
-              <a:t>5/25/16</a:t>
+              <a:t>5/26/16</a:t>
             </a:fld>
             <a:endParaRPr lang="en-US"/>
           </a:p>
@@ -610,7 +613,7 @@
           <a:p>
             <a:fld id="{57538935-E887-7942-8C81-098190EB1550}" type="datetimeFigureOut">
               <a:rPr lang="en-US" smtClean="0"/>
-              <a:t>5/25/16</a:t>
+              <a:t>5/26/16</a:t>
             </a:fld>
             <a:endParaRPr lang="en-US"/>
           </a:p>
@@ -879,7 +882,7 @@
           <a:p>
             <a:fld id="{57538935-E887-7942-8C81-098190EB1550}" type="datetimeFigureOut">
               <a:rPr lang="en-US" smtClean="0"/>
-              <a:t>5/25/16</a:t>
+              <a:t>5/26/16</a:t>
             </a:fld>
             <a:endParaRPr lang="en-US"/>
           </a:p>
@@ -1058,7 +1061,7 @@
           <a:p>
             <a:fld id="{57538935-E887-7942-8C81-098190EB1550}" type="datetimeFigureOut">
               <a:rPr lang="en-US" smtClean="0"/>
-              <a:t>5/25/16</a:t>
+              <a:t>5/26/16</a:t>
             </a:fld>
             <a:endParaRPr lang="en-US"/>
           </a:p>
@@ -1227,7 +1230,7 @@
           <a:p>
             <a:fld id="{57538935-E887-7942-8C81-098190EB1550}" type="datetimeFigureOut">
               <a:rPr lang="en-US" smtClean="0"/>
-              <a:t>5/25/16</a:t>
+              <a:t>5/26/16</a:t>
             </a:fld>
             <a:endParaRPr lang="en-US"/>
           </a:p>
@@ -1469,7 +1472,7 @@
           <a:p>
             <a:fld id="{57538935-E887-7942-8C81-098190EB1550}" type="datetimeFigureOut">
               <a:rPr lang="en-US" smtClean="0"/>
-              <a:t>5/25/16</a:t>
+              <a:t>5/26/16</a:t>
             </a:fld>
             <a:endParaRPr lang="en-US"/>
           </a:p>
@@ -1792,7 +1795,7 @@
           <a:p>
             <a:fld id="{57538935-E887-7942-8C81-098190EB1550}" type="datetimeFigureOut">
               <a:rPr lang="en-US" smtClean="0"/>
-              <a:t>5/25/16</a:t>
+              <a:t>5/26/16</a:t>
             </a:fld>
             <a:endParaRPr lang="en-US"/>
           </a:p>
@@ -2090,7 +2093,7 @@
           <a:p>
             <a:fld id="{57538935-E887-7942-8C81-098190EB1550}" type="datetimeFigureOut">
               <a:rPr lang="en-US" smtClean="0"/>
-              <a:t>5/25/16</a:t>
+              <a:t>5/26/16</a:t>
             </a:fld>
             <a:endParaRPr lang="en-US"/>
           </a:p>
@@ -2546,7 +2549,7 @@
           <a:p>
             <a:fld id="{57538935-E887-7942-8C81-098190EB1550}" type="datetimeFigureOut">
               <a:rPr lang="en-US" smtClean="0"/>
-              <a:t>5/25/16</a:t>
+              <a:t>5/26/16</a:t>
             </a:fld>
             <a:endParaRPr lang="en-US"/>
           </a:p>
@@ -2659,7 +2662,7 @@
           <a:p>
             <a:fld id="{57538935-E887-7942-8C81-098190EB1550}" type="datetimeFigureOut">
               <a:rPr lang="en-US" smtClean="0"/>
-              <a:t>5/25/16</a:t>
+              <a:t>5/26/16</a:t>
             </a:fld>
             <a:endParaRPr lang="en-US"/>
           </a:p>
@@ -2749,7 +2752,7 @@
           <a:p>
             <a:fld id="{57538935-E887-7942-8C81-098190EB1550}" type="datetimeFigureOut">
               <a:rPr lang="en-US" smtClean="0"/>
-              <a:t>5/25/16</a:t>
+              <a:t>5/26/16</a:t>
             </a:fld>
             <a:endParaRPr lang="en-US"/>
           </a:p>
@@ -3031,7 +3034,7 @@
           <a:p>
             <a:fld id="{57538935-E887-7942-8C81-098190EB1550}" type="datetimeFigureOut">
               <a:rPr lang="en-US" smtClean="0"/>
-              <a:t>5/25/16</a:t>
+              <a:t>5/26/16</a:t>
             </a:fld>
             <a:endParaRPr lang="en-US"/>
           </a:p>
@@ -3237,7 +3240,7 @@
           <a:p>
             <a:fld id="{57538935-E887-7942-8C81-098190EB1550}" type="datetimeFigureOut">
               <a:rPr lang="en-US" smtClean="0"/>
-              <a:t>5/25/16</a:t>
+              <a:t>5/26/16</a:t>
             </a:fld>
             <a:endParaRPr lang="en-US"/>
           </a:p>
@@ -3708,14 +3711,22 @@
           <a:p>
             <a:r>
               <a:rPr lang="en-US" sz="4000" dirty="0" smtClean="0"/>
-              <a:t>CHEM 565:</a:t>
+              <a:t/>
             </a:r>
             <a:br>
               <a:rPr lang="en-US" sz="4000" dirty="0" smtClean="0"/>
             </a:br>
             <a:r>
               <a:rPr lang="en-US" sz="4000" dirty="0" smtClean="0"/>
-              <a:t>Looking at Stark Effect and BOMD in DTDCPB</a:t>
+              <a:t>Application of </a:t>
+            </a:r>
+            <a:r>
+              <a:rPr lang="en-US" sz="4000" dirty="0" smtClean="0"/>
+              <a:t>BOMD for Simulating Spectra of</a:t>
+            </a:r>
+            <a:r>
+              <a:rPr lang="en-US" sz="4000" dirty="0" smtClean="0"/>
+              <a:t> Organic Semiconductors</a:t>
             </a:r>
             <a:endParaRPr lang="en-US" sz="4000" dirty="0"/>
           </a:p>
@@ -3761,8 +3772,12 @@
           </a:p>
           <a:p>
             <a:r>
+              <a:rPr lang="en-US" smtClean="0"/>
+              <a:t>J. </a:t>
+            </a:r>
+            <a:r>
               <a:rPr lang="en-US" dirty="0" smtClean="0"/>
-              <a:t>Joseph J. </a:t>
+              <a:t>J. </a:t>
             </a:r>
             <a:r>
               <a:rPr lang="en-US" dirty="0" err="1" smtClean="0"/>
@@ -3819,7 +3834,7 @@
           <a:p>
             <a:r>
               <a:rPr lang="en-US" dirty="0" smtClean="0"/>
-              <a:t>BOMD Test Case: Cyanide</a:t>
+              <a:t>Tentative DTDCPB Stark Effect Results</a:t>
             </a:r>
             <a:endParaRPr lang="en-US" dirty="0"/>
           </a:p>
@@ -3847,7 +3862,7 @@
     </p:spTree>
     <p:extLst>
       <p:ext uri="{BB962C8B-B14F-4D97-AF65-F5344CB8AC3E}">
-        <p14:creationId xmlns:p14="http://schemas.microsoft.com/office/powerpoint/2010/main" val="3578038854"/>
+        <p14:creationId xmlns:p14="http://schemas.microsoft.com/office/powerpoint/2010/main" val="3086128538"/>
       </p:ext>
     </p:extLst>
   </p:cSld>
@@ -3890,666 +3905,6 @@
           <a:lstStyle/>
           <a:p>
             <a:r>
-              <a:rPr lang="en-US" dirty="0" err="1" smtClean="0"/>
-              <a:t>Tetnative</a:t>
-            </a:r>
-            <a:r>
-              <a:rPr lang="en-US" dirty="0" smtClean="0"/>
-              <a:t> DTDCPB BOMD Results </a:t>
-            </a:r>
-            <a:endParaRPr lang="en-US" dirty="0"/>
-          </a:p>
-        </p:txBody>
-      </p:sp>
-      <p:sp>
-        <p:nvSpPr>
-          <p:cNvPr id="3" name="Content Placeholder 2"/>
-          <p:cNvSpPr>
-            <a:spLocks noGrp="1"/>
-          </p:cNvSpPr>
-          <p:nvPr>
-            <p:ph idx="1"/>
-          </p:nvPr>
-        </p:nvSpPr>
-        <p:spPr/>
-        <p:txBody>
-          <a:bodyPr/>
-          <a:lstStyle/>
-          <a:p>
-            <a:endParaRPr lang="en-US"/>
-          </a:p>
-        </p:txBody>
-      </p:sp>
-    </p:spTree>
-    <p:extLst>
-      <p:ext uri="{BB962C8B-B14F-4D97-AF65-F5344CB8AC3E}">
-        <p14:creationId xmlns:p14="http://schemas.microsoft.com/office/powerpoint/2010/main" val="3921755835"/>
-      </p:ext>
-    </p:extLst>
-  </p:cSld>
-  <p:clrMapOvr>
-    <a:masterClrMapping/>
-  </p:clrMapOvr>
-</p:sld>
-</file>
-
-<file path=ppt/slides/slide12.xml><?xml version="1.0" encoding="utf-8"?>
-<p:sld xmlns:a="http://schemas.openxmlformats.org/drawingml/2006/main" xmlns:r="http://schemas.openxmlformats.org/officeDocument/2006/relationships" xmlns:p="http://schemas.openxmlformats.org/presentationml/2006/main">
-  <p:cSld>
-    <p:spTree>
-      <p:nvGrpSpPr>
-        <p:cNvPr id="1" name=""/>
-        <p:cNvGrpSpPr/>
-        <p:nvPr/>
-      </p:nvGrpSpPr>
-      <p:grpSpPr>
-        <a:xfrm>
-          <a:off x="0" y="0"/>
-          <a:ext cx="0" cy="0"/>
-          <a:chOff x="0" y="0"/>
-          <a:chExt cx="0" cy="0"/>
-        </a:xfrm>
-      </p:grpSpPr>
-      <p:sp>
-        <p:nvSpPr>
-          <p:cNvPr id="2" name="Title 1"/>
-          <p:cNvSpPr>
-            <a:spLocks noGrp="1"/>
-          </p:cNvSpPr>
-          <p:nvPr>
-            <p:ph type="title"/>
-          </p:nvPr>
-        </p:nvSpPr>
-        <p:spPr/>
-        <p:txBody>
-          <a:bodyPr/>
-          <a:lstStyle/>
-          <a:p>
-            <a:r>
-              <a:rPr lang="en-US" dirty="0" smtClean="0"/>
-              <a:t>Conclusions and Future Directions </a:t>
-            </a:r>
-            <a:endParaRPr lang="en-US" dirty="0"/>
-          </a:p>
-        </p:txBody>
-      </p:sp>
-      <p:sp>
-        <p:nvSpPr>
-          <p:cNvPr id="3" name="Content Placeholder 2"/>
-          <p:cNvSpPr>
-            <a:spLocks noGrp="1"/>
-          </p:cNvSpPr>
-          <p:nvPr>
-            <p:ph idx="1"/>
-          </p:nvPr>
-        </p:nvSpPr>
-        <p:spPr/>
-        <p:txBody>
-          <a:bodyPr/>
-          <a:lstStyle/>
-          <a:p>
-            <a:endParaRPr lang="en-US"/>
-          </a:p>
-        </p:txBody>
-      </p:sp>
-    </p:spTree>
-    <p:extLst>
-      <p:ext uri="{BB962C8B-B14F-4D97-AF65-F5344CB8AC3E}">
-        <p14:creationId xmlns:p14="http://schemas.microsoft.com/office/powerpoint/2010/main" val="1224260026"/>
-      </p:ext>
-    </p:extLst>
-  </p:cSld>
-  <p:clrMapOvr>
-    <a:masterClrMapping/>
-  </p:clrMapOvr>
-</p:sld>
-</file>
-
-<file path=ppt/slides/slide13.xml><?xml version="1.0" encoding="utf-8"?>
-<p:sld xmlns:a="http://schemas.openxmlformats.org/drawingml/2006/main" xmlns:r="http://schemas.openxmlformats.org/officeDocument/2006/relationships" xmlns:p="http://schemas.openxmlformats.org/presentationml/2006/main">
-  <p:cSld>
-    <p:spTree>
-      <p:nvGrpSpPr>
-        <p:cNvPr id="1" name=""/>
-        <p:cNvGrpSpPr/>
-        <p:nvPr/>
-      </p:nvGrpSpPr>
-      <p:grpSpPr>
-        <a:xfrm>
-          <a:off x="0" y="0"/>
-          <a:ext cx="0" cy="0"/>
-          <a:chOff x="0" y="0"/>
-          <a:chExt cx="0" cy="0"/>
-        </a:xfrm>
-      </p:grpSpPr>
-      <p:sp>
-        <p:nvSpPr>
-          <p:cNvPr id="2" name="Title 1"/>
-          <p:cNvSpPr>
-            <a:spLocks noGrp="1"/>
-          </p:cNvSpPr>
-          <p:nvPr>
-            <p:ph type="title"/>
-          </p:nvPr>
-        </p:nvSpPr>
-        <p:spPr/>
-        <p:txBody>
-          <a:bodyPr/>
-          <a:lstStyle/>
-          <a:p>
-            <a:r>
-              <a:rPr lang="en-US" dirty="0" smtClean="0"/>
-              <a:t>Questions Slide</a:t>
-            </a:r>
-            <a:endParaRPr lang="en-US" dirty="0"/>
-          </a:p>
-        </p:txBody>
-      </p:sp>
-      <p:sp>
-        <p:nvSpPr>
-          <p:cNvPr id="3" name="Content Placeholder 2"/>
-          <p:cNvSpPr>
-            <a:spLocks noGrp="1"/>
-          </p:cNvSpPr>
-          <p:nvPr>
-            <p:ph idx="1"/>
-          </p:nvPr>
-        </p:nvSpPr>
-        <p:spPr/>
-        <p:txBody>
-          <a:bodyPr/>
-          <a:lstStyle/>
-          <a:p>
-            <a:endParaRPr lang="en-US"/>
-          </a:p>
-        </p:txBody>
-      </p:sp>
-    </p:spTree>
-    <p:extLst>
-      <p:ext uri="{BB962C8B-B14F-4D97-AF65-F5344CB8AC3E}">
-        <p14:creationId xmlns:p14="http://schemas.microsoft.com/office/powerpoint/2010/main" val="203062343"/>
-      </p:ext>
-    </p:extLst>
-  </p:cSld>
-  <p:clrMapOvr>
-    <a:masterClrMapping/>
-  </p:clrMapOvr>
-</p:sld>
-</file>
-
-<file path=ppt/slides/slide2.xml><?xml version="1.0" encoding="utf-8"?>
-<p:sld xmlns:a="http://schemas.openxmlformats.org/drawingml/2006/main" xmlns:r="http://schemas.openxmlformats.org/officeDocument/2006/relationships" xmlns:p="http://schemas.openxmlformats.org/presentationml/2006/main">
-  <p:cSld>
-    <p:spTree>
-      <p:nvGrpSpPr>
-        <p:cNvPr id="1" name=""/>
-        <p:cNvGrpSpPr/>
-        <p:nvPr/>
-      </p:nvGrpSpPr>
-      <p:grpSpPr>
-        <a:xfrm>
-          <a:off x="0" y="0"/>
-          <a:ext cx="0" cy="0"/>
-          <a:chOff x="0" y="0"/>
-          <a:chExt cx="0" cy="0"/>
-        </a:xfrm>
-      </p:grpSpPr>
-      <p:sp>
-        <p:nvSpPr>
-          <p:cNvPr id="2" name="Title 1"/>
-          <p:cNvSpPr>
-            <a:spLocks noGrp="1"/>
-          </p:cNvSpPr>
-          <p:nvPr>
-            <p:ph type="title"/>
-          </p:nvPr>
-        </p:nvSpPr>
-        <p:spPr/>
-        <p:txBody>
-          <a:bodyPr/>
-          <a:lstStyle/>
-          <a:p>
-            <a:r>
-              <a:rPr lang="en-US" sz="4000" dirty="0" smtClean="0"/>
-              <a:t>DTDCPB – What is it used for?</a:t>
-            </a:r>
-            <a:endParaRPr lang="en-US" sz="4000" dirty="0"/>
-          </a:p>
-        </p:txBody>
-      </p:sp>
-      <p:sp>
-        <p:nvSpPr>
-          <p:cNvPr id="3" name="Content Placeholder 2"/>
-          <p:cNvSpPr>
-            <a:spLocks noGrp="1"/>
-          </p:cNvSpPr>
-          <p:nvPr>
-            <p:ph idx="1"/>
-          </p:nvPr>
-        </p:nvSpPr>
-        <p:spPr/>
-        <p:txBody>
-          <a:bodyPr/>
-          <a:lstStyle/>
-          <a:p>
-            <a:r>
-              <a:rPr lang="en-US" dirty="0" smtClean="0"/>
-              <a:t>Emily will write slides </a:t>
-            </a:r>
-            <a:r>
-              <a:rPr lang="en-US" smtClean="0"/>
-              <a:t>for this part!</a:t>
-            </a:r>
-            <a:endParaRPr lang="en-US" dirty="0"/>
-          </a:p>
-        </p:txBody>
-      </p:sp>
-    </p:spTree>
-    <p:extLst>
-      <p:ext uri="{BB962C8B-B14F-4D97-AF65-F5344CB8AC3E}">
-        <p14:creationId xmlns:p14="http://schemas.microsoft.com/office/powerpoint/2010/main" val="1905753697"/>
-      </p:ext>
-    </p:extLst>
-  </p:cSld>
-  <p:clrMapOvr>
-    <a:masterClrMapping/>
-  </p:clrMapOvr>
-</p:sld>
-</file>
-
-<file path=ppt/slides/slide3.xml><?xml version="1.0" encoding="utf-8"?>
-<p:sld xmlns:a="http://schemas.openxmlformats.org/drawingml/2006/main" xmlns:r="http://schemas.openxmlformats.org/officeDocument/2006/relationships" xmlns:p="http://schemas.openxmlformats.org/presentationml/2006/main">
-  <p:cSld>
-    <p:spTree>
-      <p:nvGrpSpPr>
-        <p:cNvPr id="1" name=""/>
-        <p:cNvGrpSpPr/>
-        <p:nvPr/>
-      </p:nvGrpSpPr>
-      <p:grpSpPr>
-        <a:xfrm>
-          <a:off x="0" y="0"/>
-          <a:ext cx="0" cy="0"/>
-          <a:chOff x="0" y="0"/>
-          <a:chExt cx="0" cy="0"/>
-        </a:xfrm>
-      </p:grpSpPr>
-      <p:sp>
-        <p:nvSpPr>
-          <p:cNvPr id="2" name="Title 1"/>
-          <p:cNvSpPr>
-            <a:spLocks noGrp="1"/>
-          </p:cNvSpPr>
-          <p:nvPr>
-            <p:ph type="title"/>
-          </p:nvPr>
-        </p:nvSpPr>
-        <p:spPr/>
-        <p:txBody>
-          <a:bodyPr/>
-          <a:lstStyle/>
-          <a:p>
-            <a:r>
-              <a:rPr lang="en-US" dirty="0" smtClean="0"/>
-              <a:t>Experimental Perspective</a:t>
-            </a:r>
-            <a:endParaRPr lang="en-US" dirty="0"/>
-          </a:p>
-        </p:txBody>
-      </p:sp>
-      <p:sp>
-        <p:nvSpPr>
-          <p:cNvPr id="3" name="Content Placeholder 2"/>
-          <p:cNvSpPr>
-            <a:spLocks noGrp="1"/>
-          </p:cNvSpPr>
-          <p:nvPr>
-            <p:ph idx="1"/>
-          </p:nvPr>
-        </p:nvSpPr>
-        <p:spPr/>
-        <p:txBody>
-          <a:bodyPr/>
-          <a:lstStyle/>
-          <a:p>
-            <a:endParaRPr lang="en-US"/>
-          </a:p>
-        </p:txBody>
-      </p:sp>
-    </p:spTree>
-    <p:extLst>
-      <p:ext uri="{BB962C8B-B14F-4D97-AF65-F5344CB8AC3E}">
-        <p14:creationId xmlns:p14="http://schemas.microsoft.com/office/powerpoint/2010/main" val="3636554543"/>
-      </p:ext>
-    </p:extLst>
-  </p:cSld>
-  <p:clrMapOvr>
-    <a:masterClrMapping/>
-  </p:clrMapOvr>
-</p:sld>
-</file>
-
-<file path=ppt/slides/slide4.xml><?xml version="1.0" encoding="utf-8"?>
-<p:sld xmlns:a="http://schemas.openxmlformats.org/drawingml/2006/main" xmlns:r="http://schemas.openxmlformats.org/officeDocument/2006/relationships" xmlns:p="http://schemas.openxmlformats.org/presentationml/2006/main">
-  <p:cSld>
-    <p:spTree>
-      <p:nvGrpSpPr>
-        <p:cNvPr id="1" name=""/>
-        <p:cNvGrpSpPr/>
-        <p:nvPr/>
-      </p:nvGrpSpPr>
-      <p:grpSpPr>
-        <a:xfrm>
-          <a:off x="0" y="0"/>
-          <a:ext cx="0" cy="0"/>
-          <a:chOff x="0" y="0"/>
-          <a:chExt cx="0" cy="0"/>
-        </a:xfrm>
-      </p:grpSpPr>
-      <p:sp>
-        <p:nvSpPr>
-          <p:cNvPr id="2" name="Title 1"/>
-          <p:cNvSpPr>
-            <a:spLocks noGrp="1"/>
-          </p:cNvSpPr>
-          <p:nvPr>
-            <p:ph type="title"/>
-          </p:nvPr>
-        </p:nvSpPr>
-        <p:spPr/>
-        <p:txBody>
-          <a:bodyPr/>
-          <a:lstStyle/>
-          <a:p>
-            <a:r>
-              <a:rPr lang="en-US" dirty="0" smtClean="0"/>
-              <a:t>Experiment/Computation Combined</a:t>
-            </a:r>
-            <a:endParaRPr lang="en-US" dirty="0"/>
-          </a:p>
-        </p:txBody>
-      </p:sp>
-      <p:sp>
-        <p:nvSpPr>
-          <p:cNvPr id="3" name="Content Placeholder 2"/>
-          <p:cNvSpPr>
-            <a:spLocks noGrp="1"/>
-          </p:cNvSpPr>
-          <p:nvPr>
-            <p:ph idx="1"/>
-          </p:nvPr>
-        </p:nvSpPr>
-        <p:spPr/>
-        <p:txBody>
-          <a:bodyPr/>
-          <a:lstStyle/>
-          <a:p>
-            <a:endParaRPr lang="en-US"/>
-          </a:p>
-        </p:txBody>
-      </p:sp>
-    </p:spTree>
-    <p:extLst>
-      <p:ext uri="{BB962C8B-B14F-4D97-AF65-F5344CB8AC3E}">
-        <p14:creationId xmlns:p14="http://schemas.microsoft.com/office/powerpoint/2010/main" val="3232120331"/>
-      </p:ext>
-    </p:extLst>
-  </p:cSld>
-  <p:clrMapOvr>
-    <a:masterClrMapping/>
-  </p:clrMapOvr>
-</p:sld>
-</file>
-
-<file path=ppt/slides/slide5.xml><?xml version="1.0" encoding="utf-8"?>
-<p:sld xmlns:a="http://schemas.openxmlformats.org/drawingml/2006/main" xmlns:r="http://schemas.openxmlformats.org/officeDocument/2006/relationships" xmlns:p="http://schemas.openxmlformats.org/presentationml/2006/main">
-  <p:cSld>
-    <p:spTree>
-      <p:nvGrpSpPr>
-        <p:cNvPr id="1" name=""/>
-        <p:cNvGrpSpPr/>
-        <p:nvPr/>
-      </p:nvGrpSpPr>
-      <p:grpSpPr>
-        <a:xfrm>
-          <a:off x="0" y="0"/>
-          <a:ext cx="0" cy="0"/>
-          <a:chOff x="0" y="0"/>
-          <a:chExt cx="0" cy="0"/>
-        </a:xfrm>
-      </p:grpSpPr>
-      <p:sp>
-        <p:nvSpPr>
-          <p:cNvPr id="2" name="Title 1"/>
-          <p:cNvSpPr>
-            <a:spLocks noGrp="1"/>
-          </p:cNvSpPr>
-          <p:nvPr>
-            <p:ph type="title"/>
-          </p:nvPr>
-        </p:nvSpPr>
-        <p:spPr/>
-        <p:txBody>
-          <a:bodyPr/>
-          <a:lstStyle/>
-          <a:p>
-            <a:r>
-              <a:rPr lang="en-US" dirty="0" smtClean="0"/>
-              <a:t>Stark Effect Introduction</a:t>
-            </a:r>
-            <a:endParaRPr lang="en-US" dirty="0"/>
-          </a:p>
-        </p:txBody>
-      </p:sp>
-      <p:sp>
-        <p:nvSpPr>
-          <p:cNvPr id="3" name="Content Placeholder 2"/>
-          <p:cNvSpPr>
-            <a:spLocks noGrp="1"/>
-          </p:cNvSpPr>
-          <p:nvPr>
-            <p:ph idx="1"/>
-          </p:nvPr>
-        </p:nvSpPr>
-        <p:spPr/>
-        <p:txBody>
-          <a:bodyPr/>
-          <a:lstStyle/>
-          <a:p>
-            <a:endParaRPr lang="en-US"/>
-          </a:p>
-        </p:txBody>
-      </p:sp>
-    </p:spTree>
-    <p:extLst>
-      <p:ext uri="{BB962C8B-B14F-4D97-AF65-F5344CB8AC3E}">
-        <p14:creationId xmlns:p14="http://schemas.microsoft.com/office/powerpoint/2010/main" val="1858418337"/>
-      </p:ext>
-    </p:extLst>
-  </p:cSld>
-  <p:clrMapOvr>
-    <a:masterClrMapping/>
-  </p:clrMapOvr>
-</p:sld>
-</file>
-
-<file path=ppt/slides/slide6.xml><?xml version="1.0" encoding="utf-8"?>
-<p:sld xmlns:a="http://schemas.openxmlformats.org/drawingml/2006/main" xmlns:r="http://schemas.openxmlformats.org/officeDocument/2006/relationships" xmlns:p="http://schemas.openxmlformats.org/presentationml/2006/main">
-  <p:cSld>
-    <p:spTree>
-      <p:nvGrpSpPr>
-        <p:cNvPr id="1" name=""/>
-        <p:cNvGrpSpPr/>
-        <p:nvPr/>
-      </p:nvGrpSpPr>
-      <p:grpSpPr>
-        <a:xfrm>
-          <a:off x="0" y="0"/>
-          <a:ext cx="0" cy="0"/>
-          <a:chOff x="0" y="0"/>
-          <a:chExt cx="0" cy="0"/>
-        </a:xfrm>
-      </p:grpSpPr>
-      <p:sp>
-        <p:nvSpPr>
-          <p:cNvPr id="2" name="Title 1"/>
-          <p:cNvSpPr>
-            <a:spLocks noGrp="1"/>
-          </p:cNvSpPr>
-          <p:nvPr>
-            <p:ph type="title"/>
-          </p:nvPr>
-        </p:nvSpPr>
-        <p:spPr/>
-        <p:txBody>
-          <a:bodyPr/>
-          <a:lstStyle/>
-          <a:p>
-            <a:r>
-              <a:rPr lang="en-US" dirty="0" smtClean="0"/>
-              <a:t>Stark Effect Test Case: Cyanide</a:t>
-            </a:r>
-            <a:endParaRPr lang="en-US" dirty="0"/>
-          </a:p>
-        </p:txBody>
-      </p:sp>
-      <p:sp>
-        <p:nvSpPr>
-          <p:cNvPr id="3" name="Content Placeholder 2"/>
-          <p:cNvSpPr>
-            <a:spLocks noGrp="1"/>
-          </p:cNvSpPr>
-          <p:nvPr>
-            <p:ph idx="1"/>
-          </p:nvPr>
-        </p:nvSpPr>
-        <p:spPr/>
-        <p:txBody>
-          <a:bodyPr/>
-          <a:lstStyle/>
-          <a:p>
-            <a:endParaRPr lang="en-US"/>
-          </a:p>
-        </p:txBody>
-      </p:sp>
-    </p:spTree>
-    <p:extLst>
-      <p:ext uri="{BB962C8B-B14F-4D97-AF65-F5344CB8AC3E}">
-        <p14:creationId xmlns:p14="http://schemas.microsoft.com/office/powerpoint/2010/main" val="2440399830"/>
-      </p:ext>
-    </p:extLst>
-  </p:cSld>
-  <p:clrMapOvr>
-    <a:masterClrMapping/>
-  </p:clrMapOvr>
-</p:sld>
-</file>
-
-<file path=ppt/slides/slide7.xml><?xml version="1.0" encoding="utf-8"?>
-<p:sld xmlns:a="http://schemas.openxmlformats.org/drawingml/2006/main" xmlns:r="http://schemas.openxmlformats.org/officeDocument/2006/relationships" xmlns:p="http://schemas.openxmlformats.org/presentationml/2006/main">
-  <p:cSld>
-    <p:spTree>
-      <p:nvGrpSpPr>
-        <p:cNvPr id="1" name=""/>
-        <p:cNvGrpSpPr/>
-        <p:nvPr/>
-      </p:nvGrpSpPr>
-      <p:grpSpPr>
-        <a:xfrm>
-          <a:off x="0" y="0"/>
-          <a:ext cx="0" cy="0"/>
-          <a:chOff x="0" y="0"/>
-          <a:chExt cx="0" cy="0"/>
-        </a:xfrm>
-      </p:grpSpPr>
-      <p:sp>
-        <p:nvSpPr>
-          <p:cNvPr id="2" name="Title 1"/>
-          <p:cNvSpPr>
-            <a:spLocks noGrp="1"/>
-          </p:cNvSpPr>
-          <p:nvPr>
-            <p:ph type="title"/>
-          </p:nvPr>
-        </p:nvSpPr>
-        <p:spPr/>
-        <p:txBody>
-          <a:bodyPr/>
-          <a:lstStyle/>
-          <a:p>
-            <a:r>
-              <a:rPr lang="en-US" dirty="0" smtClean="0"/>
-              <a:t>Tentative DTDCPB Stark Effect Results</a:t>
-            </a:r>
-            <a:endParaRPr lang="en-US" dirty="0"/>
-          </a:p>
-        </p:txBody>
-      </p:sp>
-      <p:sp>
-        <p:nvSpPr>
-          <p:cNvPr id="3" name="Content Placeholder 2"/>
-          <p:cNvSpPr>
-            <a:spLocks noGrp="1"/>
-          </p:cNvSpPr>
-          <p:nvPr>
-            <p:ph idx="1"/>
-          </p:nvPr>
-        </p:nvSpPr>
-        <p:spPr/>
-        <p:txBody>
-          <a:bodyPr/>
-          <a:lstStyle/>
-          <a:p>
-            <a:endParaRPr lang="en-US"/>
-          </a:p>
-        </p:txBody>
-      </p:sp>
-    </p:spTree>
-    <p:extLst>
-      <p:ext uri="{BB962C8B-B14F-4D97-AF65-F5344CB8AC3E}">
-        <p14:creationId xmlns:p14="http://schemas.microsoft.com/office/powerpoint/2010/main" val="3086128538"/>
-      </p:ext>
-    </p:extLst>
-  </p:cSld>
-  <p:clrMapOvr>
-    <a:masterClrMapping/>
-  </p:clrMapOvr>
-</p:sld>
-</file>
-
-<file path=ppt/slides/slide8.xml><?xml version="1.0" encoding="utf-8"?>
-<p:sld xmlns:a="http://schemas.openxmlformats.org/drawingml/2006/main" xmlns:r="http://schemas.openxmlformats.org/officeDocument/2006/relationships" xmlns:p="http://schemas.openxmlformats.org/presentationml/2006/main">
-  <p:cSld>
-    <p:spTree>
-      <p:nvGrpSpPr>
-        <p:cNvPr id="1" name=""/>
-        <p:cNvGrpSpPr/>
-        <p:nvPr/>
-      </p:nvGrpSpPr>
-      <p:grpSpPr>
-        <a:xfrm>
-          <a:off x="0" y="0"/>
-          <a:ext cx="0" cy="0"/>
-          <a:chOff x="0" y="0"/>
-          <a:chExt cx="0" cy="0"/>
-        </a:xfrm>
-      </p:grpSpPr>
-      <p:sp>
-        <p:nvSpPr>
-          <p:cNvPr id="2" name="Title 1"/>
-          <p:cNvSpPr>
-            <a:spLocks noGrp="1"/>
-          </p:cNvSpPr>
-          <p:nvPr>
-            <p:ph type="title"/>
-          </p:nvPr>
-        </p:nvSpPr>
-        <p:spPr/>
-        <p:txBody>
-          <a:bodyPr/>
-          <a:lstStyle/>
-          <a:p>
-            <a:r>
               <a:rPr lang="en-US" dirty="0" smtClean="0"/>
               <a:t>BOMD Introduction</a:t>
             </a:r>
@@ -4601,7 +3956,7 @@
 </p:sld>
 </file>
 
-<file path=ppt/slides/slide9.xml><?xml version="1.0" encoding="utf-8"?>
+<file path=ppt/slides/slide12.xml><?xml version="1.0" encoding="utf-8"?>
 <p:sld xmlns:a="http://schemas.openxmlformats.org/drawingml/2006/main" xmlns:r="http://schemas.openxmlformats.org/officeDocument/2006/relationships" xmlns:p="http://schemas.openxmlformats.org/presentationml/2006/main">
   <p:cSld>
     <p:spTree>
@@ -6991,6 +6346,1178 @@
     <p:extLst>
       <p:ext uri="{BB962C8B-B14F-4D97-AF65-F5344CB8AC3E}">
         <p14:creationId xmlns:p14="http://schemas.microsoft.com/office/powerpoint/2010/main" val="224667979"/>
+      </p:ext>
+    </p:extLst>
+  </p:cSld>
+  <p:clrMapOvr>
+    <a:masterClrMapping/>
+  </p:clrMapOvr>
+</p:sld>
+</file>
+
+<file path=ppt/slides/slide13.xml><?xml version="1.0" encoding="utf-8"?>
+<p:sld xmlns:a="http://schemas.openxmlformats.org/drawingml/2006/main" xmlns:r="http://schemas.openxmlformats.org/officeDocument/2006/relationships" xmlns:p="http://schemas.openxmlformats.org/presentationml/2006/main">
+  <p:cSld>
+    <p:spTree>
+      <p:nvGrpSpPr>
+        <p:cNvPr id="1" name=""/>
+        <p:cNvGrpSpPr/>
+        <p:nvPr/>
+      </p:nvGrpSpPr>
+      <p:grpSpPr>
+        <a:xfrm>
+          <a:off x="0" y="0"/>
+          <a:ext cx="0" cy="0"/>
+          <a:chOff x="0" y="0"/>
+          <a:chExt cx="0" cy="0"/>
+        </a:xfrm>
+      </p:grpSpPr>
+      <p:sp>
+        <p:nvSpPr>
+          <p:cNvPr id="2" name="Title 1"/>
+          <p:cNvSpPr>
+            <a:spLocks noGrp="1"/>
+          </p:cNvSpPr>
+          <p:nvPr>
+            <p:ph type="title"/>
+          </p:nvPr>
+        </p:nvSpPr>
+        <p:spPr/>
+        <p:txBody>
+          <a:bodyPr/>
+          <a:lstStyle/>
+          <a:p>
+            <a:r>
+              <a:rPr lang="en-US" dirty="0" smtClean="0"/>
+              <a:t>BOMD Test Case: Cyanide</a:t>
+            </a:r>
+            <a:endParaRPr lang="en-US" dirty="0"/>
+          </a:p>
+        </p:txBody>
+      </p:sp>
+      <p:sp>
+        <p:nvSpPr>
+          <p:cNvPr id="3" name="Content Placeholder 2"/>
+          <p:cNvSpPr>
+            <a:spLocks noGrp="1"/>
+          </p:cNvSpPr>
+          <p:nvPr>
+            <p:ph idx="1"/>
+          </p:nvPr>
+        </p:nvSpPr>
+        <p:spPr/>
+        <p:txBody>
+          <a:bodyPr/>
+          <a:lstStyle/>
+          <a:p>
+            <a:endParaRPr lang="en-US"/>
+          </a:p>
+        </p:txBody>
+      </p:sp>
+    </p:spTree>
+    <p:extLst>
+      <p:ext uri="{BB962C8B-B14F-4D97-AF65-F5344CB8AC3E}">
+        <p14:creationId xmlns:p14="http://schemas.microsoft.com/office/powerpoint/2010/main" val="3578038854"/>
+      </p:ext>
+    </p:extLst>
+  </p:cSld>
+  <p:clrMapOvr>
+    <a:masterClrMapping/>
+  </p:clrMapOvr>
+</p:sld>
+</file>
+
+<file path=ppt/slides/slide14.xml><?xml version="1.0" encoding="utf-8"?>
+<p:sld xmlns:a="http://schemas.openxmlformats.org/drawingml/2006/main" xmlns:r="http://schemas.openxmlformats.org/officeDocument/2006/relationships" xmlns:p="http://schemas.openxmlformats.org/presentationml/2006/main">
+  <p:cSld>
+    <p:spTree>
+      <p:nvGrpSpPr>
+        <p:cNvPr id="1" name=""/>
+        <p:cNvGrpSpPr/>
+        <p:nvPr/>
+      </p:nvGrpSpPr>
+      <p:grpSpPr>
+        <a:xfrm>
+          <a:off x="0" y="0"/>
+          <a:ext cx="0" cy="0"/>
+          <a:chOff x="0" y="0"/>
+          <a:chExt cx="0" cy="0"/>
+        </a:xfrm>
+      </p:grpSpPr>
+      <p:sp>
+        <p:nvSpPr>
+          <p:cNvPr id="2" name="Title 1"/>
+          <p:cNvSpPr>
+            <a:spLocks noGrp="1"/>
+          </p:cNvSpPr>
+          <p:nvPr>
+            <p:ph type="title"/>
+          </p:nvPr>
+        </p:nvSpPr>
+        <p:spPr/>
+        <p:txBody>
+          <a:bodyPr/>
+          <a:lstStyle/>
+          <a:p>
+            <a:r>
+              <a:rPr lang="en-US" dirty="0" err="1" smtClean="0"/>
+              <a:t>Tetnative</a:t>
+            </a:r>
+            <a:r>
+              <a:rPr lang="en-US" dirty="0" smtClean="0"/>
+              <a:t> DTDCPB BOMD Results </a:t>
+            </a:r>
+            <a:endParaRPr lang="en-US" dirty="0"/>
+          </a:p>
+        </p:txBody>
+      </p:sp>
+      <p:sp>
+        <p:nvSpPr>
+          <p:cNvPr id="3" name="Content Placeholder 2"/>
+          <p:cNvSpPr>
+            <a:spLocks noGrp="1"/>
+          </p:cNvSpPr>
+          <p:nvPr>
+            <p:ph idx="1"/>
+          </p:nvPr>
+        </p:nvSpPr>
+        <p:spPr/>
+        <p:txBody>
+          <a:bodyPr/>
+          <a:lstStyle/>
+          <a:p>
+            <a:endParaRPr lang="en-US"/>
+          </a:p>
+        </p:txBody>
+      </p:sp>
+    </p:spTree>
+    <p:extLst>
+      <p:ext uri="{BB962C8B-B14F-4D97-AF65-F5344CB8AC3E}">
+        <p14:creationId xmlns:p14="http://schemas.microsoft.com/office/powerpoint/2010/main" val="3921755835"/>
+      </p:ext>
+    </p:extLst>
+  </p:cSld>
+  <p:clrMapOvr>
+    <a:masterClrMapping/>
+  </p:clrMapOvr>
+</p:sld>
+</file>
+
+<file path=ppt/slides/slide15.xml><?xml version="1.0" encoding="utf-8"?>
+<p:sld xmlns:a="http://schemas.openxmlformats.org/drawingml/2006/main" xmlns:r="http://schemas.openxmlformats.org/officeDocument/2006/relationships" xmlns:p="http://schemas.openxmlformats.org/presentationml/2006/main">
+  <p:cSld>
+    <p:spTree>
+      <p:nvGrpSpPr>
+        <p:cNvPr id="1" name=""/>
+        <p:cNvGrpSpPr/>
+        <p:nvPr/>
+      </p:nvGrpSpPr>
+      <p:grpSpPr>
+        <a:xfrm>
+          <a:off x="0" y="0"/>
+          <a:ext cx="0" cy="0"/>
+          <a:chOff x="0" y="0"/>
+          <a:chExt cx="0" cy="0"/>
+        </a:xfrm>
+      </p:grpSpPr>
+      <p:sp>
+        <p:nvSpPr>
+          <p:cNvPr id="2" name="Title 1"/>
+          <p:cNvSpPr>
+            <a:spLocks noGrp="1"/>
+          </p:cNvSpPr>
+          <p:nvPr>
+            <p:ph type="title"/>
+          </p:nvPr>
+        </p:nvSpPr>
+        <p:spPr/>
+        <p:txBody>
+          <a:bodyPr/>
+          <a:lstStyle/>
+          <a:p>
+            <a:r>
+              <a:rPr lang="en-US" dirty="0" smtClean="0"/>
+              <a:t>Conclusions and Future Directions </a:t>
+            </a:r>
+            <a:endParaRPr lang="en-US" dirty="0"/>
+          </a:p>
+        </p:txBody>
+      </p:sp>
+      <p:sp>
+        <p:nvSpPr>
+          <p:cNvPr id="3" name="Content Placeholder 2"/>
+          <p:cNvSpPr>
+            <a:spLocks noGrp="1"/>
+          </p:cNvSpPr>
+          <p:nvPr>
+            <p:ph idx="1"/>
+          </p:nvPr>
+        </p:nvSpPr>
+        <p:spPr/>
+        <p:txBody>
+          <a:bodyPr/>
+          <a:lstStyle/>
+          <a:p>
+            <a:endParaRPr lang="en-US"/>
+          </a:p>
+        </p:txBody>
+      </p:sp>
+    </p:spTree>
+    <p:extLst>
+      <p:ext uri="{BB962C8B-B14F-4D97-AF65-F5344CB8AC3E}">
+        <p14:creationId xmlns:p14="http://schemas.microsoft.com/office/powerpoint/2010/main" val="1224260026"/>
+      </p:ext>
+    </p:extLst>
+  </p:cSld>
+  <p:clrMapOvr>
+    <a:masterClrMapping/>
+  </p:clrMapOvr>
+</p:sld>
+</file>
+
+<file path=ppt/slides/slide16.xml><?xml version="1.0" encoding="utf-8"?>
+<p:sld xmlns:a="http://schemas.openxmlformats.org/drawingml/2006/main" xmlns:r="http://schemas.openxmlformats.org/officeDocument/2006/relationships" xmlns:p="http://schemas.openxmlformats.org/presentationml/2006/main">
+  <p:cSld>
+    <p:spTree>
+      <p:nvGrpSpPr>
+        <p:cNvPr id="1" name=""/>
+        <p:cNvGrpSpPr/>
+        <p:nvPr/>
+      </p:nvGrpSpPr>
+      <p:grpSpPr>
+        <a:xfrm>
+          <a:off x="0" y="0"/>
+          <a:ext cx="0" cy="0"/>
+          <a:chOff x="0" y="0"/>
+          <a:chExt cx="0" cy="0"/>
+        </a:xfrm>
+      </p:grpSpPr>
+      <p:sp>
+        <p:nvSpPr>
+          <p:cNvPr id="2" name="Title 1"/>
+          <p:cNvSpPr>
+            <a:spLocks noGrp="1"/>
+          </p:cNvSpPr>
+          <p:nvPr>
+            <p:ph type="title"/>
+          </p:nvPr>
+        </p:nvSpPr>
+        <p:spPr/>
+        <p:txBody>
+          <a:bodyPr/>
+          <a:lstStyle/>
+          <a:p>
+            <a:r>
+              <a:rPr lang="en-US" dirty="0" smtClean="0"/>
+              <a:t>Questions Slide</a:t>
+            </a:r>
+            <a:endParaRPr lang="en-US" dirty="0"/>
+          </a:p>
+        </p:txBody>
+      </p:sp>
+      <p:sp>
+        <p:nvSpPr>
+          <p:cNvPr id="3" name="Content Placeholder 2"/>
+          <p:cNvSpPr>
+            <a:spLocks noGrp="1"/>
+          </p:cNvSpPr>
+          <p:nvPr>
+            <p:ph idx="1"/>
+          </p:nvPr>
+        </p:nvSpPr>
+        <p:spPr/>
+        <p:txBody>
+          <a:bodyPr/>
+          <a:lstStyle/>
+          <a:p>
+            <a:endParaRPr lang="en-US"/>
+          </a:p>
+        </p:txBody>
+      </p:sp>
+    </p:spTree>
+    <p:extLst>
+      <p:ext uri="{BB962C8B-B14F-4D97-AF65-F5344CB8AC3E}">
+        <p14:creationId xmlns:p14="http://schemas.microsoft.com/office/powerpoint/2010/main" val="203062343"/>
+      </p:ext>
+    </p:extLst>
+  </p:cSld>
+  <p:clrMapOvr>
+    <a:masterClrMapping/>
+  </p:clrMapOvr>
+</p:sld>
+</file>
+
+<file path=ppt/slides/slide2.xml><?xml version="1.0" encoding="utf-8"?>
+<p:sld xmlns:a="http://schemas.openxmlformats.org/drawingml/2006/main" xmlns:r="http://schemas.openxmlformats.org/officeDocument/2006/relationships" xmlns:p="http://schemas.openxmlformats.org/presentationml/2006/main">
+  <p:cSld>
+    <p:spTree>
+      <p:nvGrpSpPr>
+        <p:cNvPr id="1" name=""/>
+        <p:cNvGrpSpPr/>
+        <p:nvPr/>
+      </p:nvGrpSpPr>
+      <p:grpSpPr>
+        <a:xfrm>
+          <a:off x="0" y="0"/>
+          <a:ext cx="0" cy="0"/>
+          <a:chOff x="0" y="0"/>
+          <a:chExt cx="0" cy="0"/>
+        </a:xfrm>
+      </p:grpSpPr>
+      <p:sp>
+        <p:nvSpPr>
+          <p:cNvPr id="2" name="Title 1"/>
+          <p:cNvSpPr>
+            <a:spLocks noGrp="1"/>
+          </p:cNvSpPr>
+          <p:nvPr>
+            <p:ph type="title"/>
+          </p:nvPr>
+        </p:nvSpPr>
+        <p:spPr/>
+        <p:txBody>
+          <a:bodyPr/>
+          <a:lstStyle/>
+          <a:p>
+            <a:r>
+              <a:rPr lang="en-US" sz="4000" dirty="0" smtClean="0"/>
+              <a:t>DTDCPB – What is it used for?</a:t>
+            </a:r>
+            <a:endParaRPr lang="en-US" sz="4000" dirty="0"/>
+          </a:p>
+        </p:txBody>
+      </p:sp>
+      <p:sp>
+        <p:nvSpPr>
+          <p:cNvPr id="3" name="Content Placeholder 2"/>
+          <p:cNvSpPr>
+            <a:spLocks noGrp="1"/>
+          </p:cNvSpPr>
+          <p:nvPr>
+            <p:ph idx="1"/>
+          </p:nvPr>
+        </p:nvSpPr>
+        <p:spPr/>
+        <p:txBody>
+          <a:bodyPr/>
+          <a:lstStyle/>
+          <a:p>
+            <a:r>
+              <a:rPr lang="en-US" dirty="0" smtClean="0"/>
+              <a:t>Emily will write slides </a:t>
+            </a:r>
+            <a:r>
+              <a:rPr lang="en-US" smtClean="0"/>
+              <a:t>for this part!</a:t>
+            </a:r>
+            <a:endParaRPr lang="en-US" dirty="0"/>
+          </a:p>
+        </p:txBody>
+      </p:sp>
+    </p:spTree>
+    <p:extLst>
+      <p:ext uri="{BB962C8B-B14F-4D97-AF65-F5344CB8AC3E}">
+        <p14:creationId xmlns:p14="http://schemas.microsoft.com/office/powerpoint/2010/main" val="1905753697"/>
+      </p:ext>
+    </p:extLst>
+  </p:cSld>
+  <p:clrMapOvr>
+    <a:masterClrMapping/>
+  </p:clrMapOvr>
+</p:sld>
+</file>
+
+<file path=ppt/slides/slide3.xml><?xml version="1.0" encoding="utf-8"?>
+<p:sld xmlns:a="http://schemas.openxmlformats.org/drawingml/2006/main" xmlns:r="http://schemas.openxmlformats.org/officeDocument/2006/relationships" xmlns:p="http://schemas.openxmlformats.org/presentationml/2006/main">
+  <p:cSld>
+    <p:spTree>
+      <p:nvGrpSpPr>
+        <p:cNvPr id="1" name=""/>
+        <p:cNvGrpSpPr/>
+        <p:nvPr/>
+      </p:nvGrpSpPr>
+      <p:grpSpPr>
+        <a:xfrm>
+          <a:off x="0" y="0"/>
+          <a:ext cx="0" cy="0"/>
+          <a:chOff x="0" y="0"/>
+          <a:chExt cx="0" cy="0"/>
+        </a:xfrm>
+      </p:grpSpPr>
+      <p:pic>
+        <p:nvPicPr>
+          <p:cNvPr id="4" name="Picture 3" descr="DTDCPB.png"/>
+          <p:cNvPicPr>
+            <a:picLocks noChangeAspect="1"/>
+          </p:cNvPicPr>
+          <p:nvPr/>
+        </p:nvPicPr>
+        <p:blipFill>
+          <a:blip r:embed="rId2">
+            <a:extLst>
+              <a:ext uri="{28A0092B-C50C-407E-A947-70E740481C1C}">
+                <a14:useLocalDpi xmlns:a14="http://schemas.microsoft.com/office/drawing/2010/main" val="0"/>
+              </a:ext>
+            </a:extLst>
+          </a:blip>
+          <a:stretch>
+            <a:fillRect/>
+          </a:stretch>
+        </p:blipFill>
+        <p:spPr>
+          <a:xfrm>
+            <a:off x="4864069" y="1600201"/>
+            <a:ext cx="3584509" cy="4411703"/>
+          </a:xfrm>
+          <a:prstGeom prst="rect">
+            <a:avLst/>
+          </a:prstGeom>
+        </p:spPr>
+      </p:pic>
+      <p:sp>
+        <p:nvSpPr>
+          <p:cNvPr id="2" name="Title 1"/>
+          <p:cNvSpPr>
+            <a:spLocks noGrp="1"/>
+          </p:cNvSpPr>
+          <p:nvPr>
+            <p:ph type="title"/>
+          </p:nvPr>
+        </p:nvSpPr>
+        <p:spPr/>
+        <p:txBody>
+          <a:bodyPr>
+            <a:normAutofit/>
+          </a:bodyPr>
+          <a:lstStyle/>
+          <a:p>
+            <a:r>
+              <a:rPr lang="en-US" dirty="0" smtClean="0"/>
+              <a:t>DTDCPB</a:t>
+            </a:r>
+            <a:endParaRPr lang="en-US" dirty="0"/>
+          </a:p>
+        </p:txBody>
+      </p:sp>
+      <p:sp>
+        <p:nvSpPr>
+          <p:cNvPr id="3" name="Content Placeholder 2"/>
+          <p:cNvSpPr>
+            <a:spLocks noGrp="1"/>
+          </p:cNvSpPr>
+          <p:nvPr>
+            <p:ph sz="half" idx="1"/>
+          </p:nvPr>
+        </p:nvSpPr>
+        <p:spPr>
+          <a:xfrm>
+            <a:off x="549275" y="1600201"/>
+            <a:ext cx="4144380" cy="4343400"/>
+          </a:xfrm>
+        </p:spPr>
+        <p:txBody>
+          <a:bodyPr/>
+          <a:lstStyle/>
+          <a:p>
+            <a:r>
+              <a:rPr lang="en-US" sz="2400" dirty="0" smtClean="0"/>
+              <a:t>Importance of OSC – cost effective, flexible</a:t>
+            </a:r>
+          </a:p>
+          <a:p>
+            <a:r>
+              <a:rPr lang="en-US" sz="2400" dirty="0" smtClean="0"/>
+              <a:t>DTDCPB has “DAA” molecular configuration –smaller </a:t>
+            </a:r>
+            <a:r>
+              <a:rPr lang="en-US" sz="2400" dirty="0" err="1" smtClean="0"/>
+              <a:t>bandgap</a:t>
+            </a:r>
+            <a:r>
+              <a:rPr lang="en-US" sz="2400" dirty="0" smtClean="0"/>
+              <a:t> and low HOMO</a:t>
+            </a:r>
+          </a:p>
+          <a:p>
+            <a:r>
+              <a:rPr lang="en-US" sz="2400" dirty="0" smtClean="0"/>
+              <a:t>Can act as fairly good donor in OSC (around 6% efficiency)</a:t>
+            </a:r>
+          </a:p>
+          <a:p>
+            <a:endParaRPr lang="en-US" dirty="0"/>
+          </a:p>
+        </p:txBody>
+      </p:sp>
+    </p:spTree>
+    <p:extLst>
+      <p:ext uri="{BB962C8B-B14F-4D97-AF65-F5344CB8AC3E}">
+        <p14:creationId xmlns:p14="http://schemas.microsoft.com/office/powerpoint/2010/main" val="750567203"/>
+      </p:ext>
+    </p:extLst>
+  </p:cSld>
+  <p:clrMapOvr>
+    <a:masterClrMapping/>
+  </p:clrMapOvr>
+  <p:timing>
+    <p:tnLst>
+      <p:par>
+        <p:cTn id="1" dur="indefinite" restart="never" nodeType="tmRoot"/>
+      </p:par>
+    </p:tnLst>
+  </p:timing>
+</p:sld>
+</file>
+
+<file path=ppt/slides/slide4.xml><?xml version="1.0" encoding="utf-8"?>
+<p:sld xmlns:a="http://schemas.openxmlformats.org/drawingml/2006/main" xmlns:r="http://schemas.openxmlformats.org/officeDocument/2006/relationships" xmlns:p="http://schemas.openxmlformats.org/presentationml/2006/main">
+  <p:cSld>
+    <p:spTree>
+      <p:nvGrpSpPr>
+        <p:cNvPr id="1" name=""/>
+        <p:cNvGrpSpPr/>
+        <p:nvPr/>
+      </p:nvGrpSpPr>
+      <p:grpSpPr>
+        <a:xfrm>
+          <a:off x="0" y="0"/>
+          <a:ext cx="0" cy="0"/>
+          <a:chOff x="0" y="0"/>
+          <a:chExt cx="0" cy="0"/>
+        </a:xfrm>
+      </p:grpSpPr>
+      <p:sp>
+        <p:nvSpPr>
+          <p:cNvPr id="2" name="Title 1"/>
+          <p:cNvSpPr>
+            <a:spLocks noGrp="1"/>
+          </p:cNvSpPr>
+          <p:nvPr>
+            <p:ph type="title"/>
+          </p:nvPr>
+        </p:nvSpPr>
+        <p:spPr/>
+        <p:txBody>
+          <a:bodyPr/>
+          <a:lstStyle/>
+          <a:p>
+            <a:r>
+              <a:rPr lang="en-US" dirty="0" smtClean="0"/>
+              <a:t>Experimental Perspective</a:t>
+            </a:r>
+            <a:endParaRPr lang="en-US" dirty="0"/>
+          </a:p>
+        </p:txBody>
+      </p:sp>
+      <p:sp>
+        <p:nvSpPr>
+          <p:cNvPr id="3" name="Content Placeholder 2"/>
+          <p:cNvSpPr>
+            <a:spLocks noGrp="1"/>
+          </p:cNvSpPr>
+          <p:nvPr>
+            <p:ph idx="1"/>
+          </p:nvPr>
+        </p:nvSpPr>
+        <p:spPr/>
+        <p:txBody>
+          <a:bodyPr/>
+          <a:lstStyle/>
+          <a:p>
+            <a:endParaRPr lang="en-US"/>
+          </a:p>
+        </p:txBody>
+      </p:sp>
+    </p:spTree>
+    <p:extLst>
+      <p:ext uri="{BB962C8B-B14F-4D97-AF65-F5344CB8AC3E}">
+        <p14:creationId xmlns:p14="http://schemas.microsoft.com/office/powerpoint/2010/main" val="3636554543"/>
+      </p:ext>
+    </p:extLst>
+  </p:cSld>
+  <p:clrMapOvr>
+    <a:masterClrMapping/>
+  </p:clrMapOvr>
+</p:sld>
+</file>
+
+<file path=ppt/slides/slide5.xml><?xml version="1.0" encoding="utf-8"?>
+<p:sld xmlns:a="http://schemas.openxmlformats.org/drawingml/2006/main" xmlns:r="http://schemas.openxmlformats.org/officeDocument/2006/relationships" xmlns:p="http://schemas.openxmlformats.org/presentationml/2006/main">
+  <p:cSld>
+    <p:spTree>
+      <p:nvGrpSpPr>
+        <p:cNvPr id="1" name=""/>
+        <p:cNvGrpSpPr/>
+        <p:nvPr/>
+      </p:nvGrpSpPr>
+      <p:grpSpPr>
+        <a:xfrm>
+          <a:off x="0" y="0"/>
+          <a:ext cx="0" cy="0"/>
+          <a:chOff x="0" y="0"/>
+          <a:chExt cx="0" cy="0"/>
+        </a:xfrm>
+      </p:grpSpPr>
+      <p:sp>
+        <p:nvSpPr>
+          <p:cNvPr id="2" name="Title 1"/>
+          <p:cNvSpPr>
+            <a:spLocks noGrp="1"/>
+          </p:cNvSpPr>
+          <p:nvPr>
+            <p:ph type="title"/>
+          </p:nvPr>
+        </p:nvSpPr>
+        <p:spPr/>
+        <p:txBody>
+          <a:bodyPr/>
+          <a:lstStyle/>
+          <a:p>
+            <a:r>
+              <a:rPr lang="en-US" dirty="0" smtClean="0"/>
+              <a:t>Experiment/Computation Combined</a:t>
+            </a:r>
+            <a:endParaRPr lang="en-US" dirty="0"/>
+          </a:p>
+        </p:txBody>
+      </p:sp>
+      <p:sp>
+        <p:nvSpPr>
+          <p:cNvPr id="3" name="Content Placeholder 2"/>
+          <p:cNvSpPr>
+            <a:spLocks noGrp="1"/>
+          </p:cNvSpPr>
+          <p:nvPr>
+            <p:ph idx="1"/>
+          </p:nvPr>
+        </p:nvSpPr>
+        <p:spPr/>
+        <p:txBody>
+          <a:bodyPr/>
+          <a:lstStyle/>
+          <a:p>
+            <a:endParaRPr lang="en-US"/>
+          </a:p>
+        </p:txBody>
+      </p:sp>
+    </p:spTree>
+    <p:extLst>
+      <p:ext uri="{BB962C8B-B14F-4D97-AF65-F5344CB8AC3E}">
+        <p14:creationId xmlns:p14="http://schemas.microsoft.com/office/powerpoint/2010/main" val="3232120331"/>
+      </p:ext>
+    </p:extLst>
+  </p:cSld>
+  <p:clrMapOvr>
+    <a:masterClrMapping/>
+  </p:clrMapOvr>
+</p:sld>
+</file>
+
+<file path=ppt/slides/slide6.xml><?xml version="1.0" encoding="utf-8"?>
+<p:sld xmlns:a="http://schemas.openxmlformats.org/drawingml/2006/main" xmlns:r="http://schemas.openxmlformats.org/officeDocument/2006/relationships" xmlns:p="http://schemas.openxmlformats.org/presentationml/2006/main">
+  <p:cSld>
+    <p:spTree>
+      <p:nvGrpSpPr>
+        <p:cNvPr id="1" name=""/>
+        <p:cNvGrpSpPr/>
+        <p:nvPr/>
+      </p:nvGrpSpPr>
+      <p:grpSpPr>
+        <a:xfrm>
+          <a:off x="0" y="0"/>
+          <a:ext cx="0" cy="0"/>
+          <a:chOff x="0" y="0"/>
+          <a:chExt cx="0" cy="0"/>
+        </a:xfrm>
+      </p:grpSpPr>
+      <p:sp>
+        <p:nvSpPr>
+          <p:cNvPr id="2" name="Title 1"/>
+          <p:cNvSpPr>
+            <a:spLocks noGrp="1"/>
+          </p:cNvSpPr>
+          <p:nvPr>
+            <p:ph type="title"/>
+          </p:nvPr>
+        </p:nvSpPr>
+        <p:spPr/>
+        <p:txBody>
+          <a:bodyPr/>
+          <a:lstStyle/>
+          <a:p>
+            <a:r>
+              <a:rPr lang="en-US" dirty="0" smtClean="0"/>
+              <a:t>Computational Methods</a:t>
+            </a:r>
+            <a:endParaRPr lang="en-US" dirty="0"/>
+          </a:p>
+        </p:txBody>
+      </p:sp>
+      <p:sp>
+        <p:nvSpPr>
+          <p:cNvPr id="3" name="Content Placeholder 2"/>
+          <p:cNvSpPr>
+            <a:spLocks noGrp="1"/>
+          </p:cNvSpPr>
+          <p:nvPr>
+            <p:ph idx="1"/>
+          </p:nvPr>
+        </p:nvSpPr>
+        <p:spPr/>
+        <p:txBody>
+          <a:bodyPr/>
+          <a:lstStyle/>
+          <a:p>
+            <a:endParaRPr lang="en-US"/>
+          </a:p>
+        </p:txBody>
+      </p:sp>
+    </p:spTree>
+    <p:extLst>
+      <p:ext uri="{BB962C8B-B14F-4D97-AF65-F5344CB8AC3E}">
+        <p14:creationId xmlns:p14="http://schemas.microsoft.com/office/powerpoint/2010/main" val="1292668253"/>
+      </p:ext>
+    </p:extLst>
+  </p:cSld>
+  <p:clrMapOvr>
+    <a:masterClrMapping/>
+  </p:clrMapOvr>
+</p:sld>
+</file>
+
+<file path=ppt/slides/slide7.xml><?xml version="1.0" encoding="utf-8"?>
+<p:sld xmlns:a="http://schemas.openxmlformats.org/drawingml/2006/main" xmlns:r="http://schemas.openxmlformats.org/officeDocument/2006/relationships" xmlns:p="http://schemas.openxmlformats.org/presentationml/2006/main">
+  <p:cSld>
+    <p:spTree>
+      <p:nvGrpSpPr>
+        <p:cNvPr id="1" name=""/>
+        <p:cNvGrpSpPr/>
+        <p:nvPr/>
+      </p:nvGrpSpPr>
+      <p:grpSpPr>
+        <a:xfrm>
+          <a:off x="0" y="0"/>
+          <a:ext cx="0" cy="0"/>
+          <a:chOff x="0" y="0"/>
+          <a:chExt cx="0" cy="0"/>
+        </a:xfrm>
+      </p:grpSpPr>
+      <p:sp>
+        <p:nvSpPr>
+          <p:cNvPr id="2" name="Title 1"/>
+          <p:cNvSpPr>
+            <a:spLocks noGrp="1"/>
+          </p:cNvSpPr>
+          <p:nvPr>
+            <p:ph type="title"/>
+          </p:nvPr>
+        </p:nvSpPr>
+        <p:spPr/>
+        <p:txBody>
+          <a:bodyPr/>
+          <a:lstStyle/>
+          <a:p>
+            <a:r>
+              <a:rPr lang="en-US" dirty="0" smtClean="0"/>
+              <a:t>Simulating Spectra</a:t>
+            </a:r>
+            <a:endParaRPr lang="en-US" dirty="0"/>
+          </a:p>
+        </p:txBody>
+      </p:sp>
+      <p:sp>
+        <p:nvSpPr>
+          <p:cNvPr id="3" name="Content Placeholder 2"/>
+          <p:cNvSpPr>
+            <a:spLocks noGrp="1"/>
+          </p:cNvSpPr>
+          <p:nvPr>
+            <p:ph idx="1"/>
+          </p:nvPr>
+        </p:nvSpPr>
+        <p:spPr>
+          <a:xfrm>
+            <a:off x="549275" y="1600200"/>
+            <a:ext cx="8042276" cy="4914899"/>
+          </a:xfrm>
+        </p:spPr>
+        <p:txBody>
+          <a:bodyPr/>
+          <a:lstStyle/>
+          <a:p>
+            <a:r>
+              <a:rPr lang="en-US" dirty="0" smtClean="0"/>
+              <a:t>Dipole moment calculation </a:t>
+            </a:r>
+            <a:r>
+              <a:rPr lang="en-US" dirty="0" smtClean="0"/>
+              <a:t>from nuclear motion:</a:t>
+            </a:r>
+            <a:endParaRPr lang="en-US" dirty="0" smtClean="0"/>
+          </a:p>
+          <a:p>
+            <a:pPr lvl="1"/>
+            <a:r>
+              <a:rPr lang="en-US" dirty="0" err="1" smtClean="0"/>
+              <a:t>Wannier</a:t>
+            </a:r>
+            <a:r>
+              <a:rPr lang="en-US" dirty="0" smtClean="0"/>
+              <a:t> function </a:t>
+            </a:r>
+            <a:r>
+              <a:rPr lang="en-US" dirty="0" smtClean="0"/>
+              <a:t>(Example)</a:t>
+            </a:r>
+            <a:endParaRPr lang="en-US" dirty="0" smtClean="0"/>
+          </a:p>
+          <a:p>
+            <a:pPr lvl="1"/>
+            <a:endParaRPr lang="en-US" dirty="0" smtClean="0"/>
+          </a:p>
+          <a:p>
+            <a:r>
+              <a:rPr lang="en-US" dirty="0" smtClean="0"/>
+              <a:t>Velocity </a:t>
+            </a:r>
+            <a:r>
+              <a:rPr lang="en-US" dirty="0" err="1" smtClean="0"/>
+              <a:t>Verlet</a:t>
+            </a:r>
+            <a:r>
+              <a:rPr lang="en-US" dirty="0" smtClean="0"/>
+              <a:t> Algorithm </a:t>
+            </a:r>
+            <a:r>
+              <a:rPr lang="en-US" dirty="0" smtClean="0"/>
+              <a:t>for MD:</a:t>
+            </a:r>
+            <a:endParaRPr lang="en-US" dirty="0" smtClean="0"/>
+          </a:p>
+          <a:p>
+            <a:endParaRPr lang="en-US" dirty="0" smtClean="0"/>
+          </a:p>
+          <a:p>
+            <a:endParaRPr lang="en-US" dirty="0" smtClean="0"/>
+          </a:p>
+          <a:p>
+            <a:r>
+              <a:rPr lang="en-US" dirty="0" smtClean="0"/>
+              <a:t>Obtaining spectra in </a:t>
+            </a:r>
+            <a:r>
+              <a:rPr lang="en-US" dirty="0" err="1" smtClean="0"/>
+              <a:t>Postprocessing</a:t>
+            </a:r>
+            <a:endParaRPr lang="en-US" dirty="0" smtClean="0"/>
+          </a:p>
+        </p:txBody>
+      </p:sp>
+      <p:pic>
+        <p:nvPicPr>
+          <p:cNvPr id="4" name="Picture 3"/>
+          <p:cNvPicPr>
+            <a:picLocks noChangeAspect="1"/>
+          </p:cNvPicPr>
+          <p:nvPr/>
+        </p:nvPicPr>
+        <p:blipFill>
+          <a:blip r:embed="rId2"/>
+          <a:stretch>
+            <a:fillRect/>
+          </a:stretch>
+        </p:blipFill>
+        <p:spPr>
+          <a:xfrm>
+            <a:off x="3177846" y="2528732"/>
+            <a:ext cx="2797833" cy="538793"/>
+          </a:xfrm>
+          <a:prstGeom prst="rect">
+            <a:avLst/>
+          </a:prstGeom>
+        </p:spPr>
+      </p:pic>
+      <p:pic>
+        <p:nvPicPr>
+          <p:cNvPr id="5" name="Picture 4"/>
+          <p:cNvPicPr>
+            <a:picLocks noChangeAspect="1"/>
+          </p:cNvPicPr>
+          <p:nvPr/>
+        </p:nvPicPr>
+        <p:blipFill>
+          <a:blip r:embed="rId3">
+            <a:extLst>
+              <a:ext uri="{28A0092B-C50C-407E-A947-70E740481C1C}">
+                <a14:useLocalDpi xmlns:a14="http://schemas.microsoft.com/office/drawing/2010/main" val="0"/>
+              </a:ext>
+            </a:extLst>
+          </a:blip>
+          <a:stretch>
+            <a:fillRect/>
+          </a:stretch>
+        </p:blipFill>
+        <p:spPr>
+          <a:xfrm>
+            <a:off x="2493963" y="3613015"/>
+            <a:ext cx="4152900" cy="520700"/>
+          </a:xfrm>
+          <a:prstGeom prst="rect">
+            <a:avLst/>
+          </a:prstGeom>
+        </p:spPr>
+      </p:pic>
+      <p:pic>
+        <p:nvPicPr>
+          <p:cNvPr id="6" name="Picture 5"/>
+          <p:cNvPicPr>
+            <a:picLocks noChangeAspect="1"/>
+          </p:cNvPicPr>
+          <p:nvPr/>
+        </p:nvPicPr>
+        <p:blipFill>
+          <a:blip r:embed="rId4">
+            <a:extLst>
+              <a:ext uri="{28A0092B-C50C-407E-A947-70E740481C1C}">
+                <a14:useLocalDpi xmlns:a14="http://schemas.microsoft.com/office/drawing/2010/main" val="0"/>
+              </a:ext>
+            </a:extLst>
+          </a:blip>
+          <a:stretch>
+            <a:fillRect/>
+          </a:stretch>
+        </p:blipFill>
+        <p:spPr>
+          <a:xfrm>
+            <a:off x="2506663" y="4250076"/>
+            <a:ext cx="4140200" cy="546100"/>
+          </a:xfrm>
+          <a:prstGeom prst="rect">
+            <a:avLst/>
+          </a:prstGeom>
+        </p:spPr>
+      </p:pic>
+      <p:pic>
+        <p:nvPicPr>
+          <p:cNvPr id="7" name="Picture 6"/>
+          <p:cNvPicPr>
+            <a:picLocks noChangeAspect="1"/>
+          </p:cNvPicPr>
+          <p:nvPr/>
+        </p:nvPicPr>
+        <p:blipFill>
+          <a:blip r:embed="rId5"/>
+          <a:stretch>
+            <a:fillRect/>
+          </a:stretch>
+        </p:blipFill>
+        <p:spPr>
+          <a:xfrm>
+            <a:off x="2591934" y="5503122"/>
+            <a:ext cx="3956957" cy="643408"/>
+          </a:xfrm>
+          <a:prstGeom prst="rect">
+            <a:avLst/>
+          </a:prstGeom>
+        </p:spPr>
+      </p:pic>
+      <p:sp>
+        <p:nvSpPr>
+          <p:cNvPr id="10" name="Curved Left Arrow 9"/>
+          <p:cNvSpPr/>
+          <p:nvPr/>
+        </p:nvSpPr>
+        <p:spPr>
+          <a:xfrm>
+            <a:off x="6642090" y="2531153"/>
+            <a:ext cx="834390" cy="3423877"/>
+          </a:xfrm>
+          <a:prstGeom prst="curvedLeftArrow">
+            <a:avLst/>
+          </a:prstGeom>
+        </p:spPr>
+        <p:style>
+          <a:lnRef idx="1">
+            <a:schemeClr val="accent1"/>
+          </a:lnRef>
+          <a:fillRef idx="3">
+            <a:schemeClr val="accent1"/>
+          </a:fillRef>
+          <a:effectRef idx="2">
+            <a:schemeClr val="accent1"/>
+          </a:effectRef>
+          <a:fontRef idx="minor">
+            <a:schemeClr val="lt1"/>
+          </a:fontRef>
+        </p:style>
+        <p:txBody>
+          <a:bodyPr rtlCol="0" anchor="ctr"/>
+          <a:lstStyle/>
+          <a:p>
+            <a:pPr algn="ctr"/>
+            <a:endParaRPr lang="en-US">
+              <a:solidFill>
+                <a:schemeClr val="tx1"/>
+              </a:solidFill>
+            </a:endParaRPr>
+          </a:p>
+        </p:txBody>
+      </p:sp>
+    </p:spTree>
+    <p:extLst>
+      <p:ext uri="{BB962C8B-B14F-4D97-AF65-F5344CB8AC3E}">
+        <p14:creationId xmlns:p14="http://schemas.microsoft.com/office/powerpoint/2010/main" val="396060207"/>
+      </p:ext>
+    </p:extLst>
+  </p:cSld>
+  <p:clrMapOvr>
+    <a:masterClrMapping/>
+  </p:clrMapOvr>
+  <p:timing>
+    <p:tnLst>
+      <p:par>
+        <p:cTn id="1" dur="indefinite" restart="never" nodeType="tmRoot"/>
+      </p:par>
+    </p:tnLst>
+  </p:timing>
+</p:sld>
+</file>
+
+<file path=ppt/slides/slide8.xml><?xml version="1.0" encoding="utf-8"?>
+<p:sld xmlns:a="http://schemas.openxmlformats.org/drawingml/2006/main" xmlns:r="http://schemas.openxmlformats.org/officeDocument/2006/relationships" xmlns:p="http://schemas.openxmlformats.org/presentationml/2006/main">
+  <p:cSld>
+    <p:spTree>
+      <p:nvGrpSpPr>
+        <p:cNvPr id="1" name=""/>
+        <p:cNvGrpSpPr/>
+        <p:nvPr/>
+      </p:nvGrpSpPr>
+      <p:grpSpPr>
+        <a:xfrm>
+          <a:off x="0" y="0"/>
+          <a:ext cx="0" cy="0"/>
+          <a:chOff x="0" y="0"/>
+          <a:chExt cx="0" cy="0"/>
+        </a:xfrm>
+      </p:grpSpPr>
+      <p:sp>
+        <p:nvSpPr>
+          <p:cNvPr id="2" name="Title 1"/>
+          <p:cNvSpPr>
+            <a:spLocks noGrp="1"/>
+          </p:cNvSpPr>
+          <p:nvPr>
+            <p:ph type="title"/>
+          </p:nvPr>
+        </p:nvSpPr>
+        <p:spPr/>
+        <p:txBody>
+          <a:bodyPr/>
+          <a:lstStyle/>
+          <a:p>
+            <a:r>
+              <a:rPr lang="en-US" dirty="0" smtClean="0"/>
+              <a:t>Stark Effect Introduction</a:t>
+            </a:r>
+            <a:endParaRPr lang="en-US" dirty="0"/>
+          </a:p>
+        </p:txBody>
+      </p:sp>
+      <p:sp>
+        <p:nvSpPr>
+          <p:cNvPr id="3" name="Content Placeholder 2"/>
+          <p:cNvSpPr>
+            <a:spLocks noGrp="1"/>
+          </p:cNvSpPr>
+          <p:nvPr>
+            <p:ph idx="1"/>
+          </p:nvPr>
+        </p:nvSpPr>
+        <p:spPr/>
+        <p:txBody>
+          <a:bodyPr/>
+          <a:lstStyle/>
+          <a:p>
+            <a:endParaRPr lang="en-US"/>
+          </a:p>
+        </p:txBody>
+      </p:sp>
+    </p:spTree>
+    <p:extLst>
+      <p:ext uri="{BB962C8B-B14F-4D97-AF65-F5344CB8AC3E}">
+        <p14:creationId xmlns:p14="http://schemas.microsoft.com/office/powerpoint/2010/main" val="1858418337"/>
+      </p:ext>
+    </p:extLst>
+  </p:cSld>
+  <p:clrMapOvr>
+    <a:masterClrMapping/>
+  </p:clrMapOvr>
+</p:sld>
+</file>
+
+<file path=ppt/slides/slide9.xml><?xml version="1.0" encoding="utf-8"?>
+<p:sld xmlns:a="http://schemas.openxmlformats.org/drawingml/2006/main" xmlns:r="http://schemas.openxmlformats.org/officeDocument/2006/relationships" xmlns:p="http://schemas.openxmlformats.org/presentationml/2006/main">
+  <p:cSld>
+    <p:spTree>
+      <p:nvGrpSpPr>
+        <p:cNvPr id="1" name=""/>
+        <p:cNvGrpSpPr/>
+        <p:nvPr/>
+      </p:nvGrpSpPr>
+      <p:grpSpPr>
+        <a:xfrm>
+          <a:off x="0" y="0"/>
+          <a:ext cx="0" cy="0"/>
+          <a:chOff x="0" y="0"/>
+          <a:chExt cx="0" cy="0"/>
+        </a:xfrm>
+      </p:grpSpPr>
+      <p:sp>
+        <p:nvSpPr>
+          <p:cNvPr id="2" name="Title 1"/>
+          <p:cNvSpPr>
+            <a:spLocks noGrp="1"/>
+          </p:cNvSpPr>
+          <p:nvPr>
+            <p:ph type="title"/>
+          </p:nvPr>
+        </p:nvSpPr>
+        <p:spPr/>
+        <p:txBody>
+          <a:bodyPr/>
+          <a:lstStyle/>
+          <a:p>
+            <a:r>
+              <a:rPr lang="en-US" dirty="0" smtClean="0"/>
+              <a:t>Stark Effect Test Case: Cyanide</a:t>
+            </a:r>
+            <a:endParaRPr lang="en-US" dirty="0"/>
+          </a:p>
+        </p:txBody>
+      </p:sp>
+      <p:sp>
+        <p:nvSpPr>
+          <p:cNvPr id="3" name="Content Placeholder 2"/>
+          <p:cNvSpPr>
+            <a:spLocks noGrp="1"/>
+          </p:cNvSpPr>
+          <p:nvPr>
+            <p:ph idx="1"/>
+          </p:nvPr>
+        </p:nvSpPr>
+        <p:spPr/>
+        <p:txBody>
+          <a:bodyPr/>
+          <a:lstStyle/>
+          <a:p>
+            <a:endParaRPr lang="en-US"/>
+          </a:p>
+        </p:txBody>
+      </p:sp>
+    </p:spTree>
+    <p:extLst>
+      <p:ext uri="{BB962C8B-B14F-4D97-AF65-F5344CB8AC3E}">
+        <p14:creationId xmlns:p14="http://schemas.microsoft.com/office/powerpoint/2010/main" val="2440399830"/>
       </p:ext>
     </p:extLst>
   </p:cSld>

</xml_diff>